<commit_message>
Connect class 2 opening to Transformer architecture and class 1 recap
</commit_message>
<xml_diff>
--- a/class2/class2_tokens_embeddings_positions.pptx
+++ b/class2/class2_tokens_embeddings_positions.pptx
@@ -526,32 +526,32 @@
           </a:p>
           <a:p>
             <a:r>
-              <a:t>第二课：输入表示的算法与机制</a:t>
-            </a:r>
-          </a:p>
-          <a:p>
-            <a:r>
-              <a:t>Tokenizer：怎样学习规则，怎样执行编码</a:t>
-            </a:r>
-          </a:p>
-          <a:p>
-            <a:r>
-              <a:t>Embedding：怎样选行，误差怎样更新表</a:t>
-            </a:r>
-          </a:p>
-          <a:p>
-            <a:r>
-              <a:t>位置机制：顺序怎样进入 Q/K 计算</a:t>
-            </a:r>
-          </a:p>
-          <a:p>
-            <a:r>
-              <a:t>文本 → token ID → 可训练向量 → 位置机制 → Attention</a:t>
-            </a:r>
-          </a:p>
-          <a:p>
-            <a:r>
-              <a:t>沿用第一课的Q/K/V概念，新增B、T、D、V四个形状符号。本课有字符级BPE机制实验与真实ByteLevel BPE实现，两者的词表和ID不混用。课堂运行已保存的本地配置，不下载预训练模型。准备阶段安装Tokenizers与PyTorch。</a:t>
+              <a:t>回顾：Transformer 的完整生成架构</a:t>
+            </a:r>
+          </a:p>
+          <a:p>
+            <a:r>
+              <a:t>文本编码为ID，经Embedding成为[B,T,D]向量。</a:t>
+            </a:r>
+          </a:p>
+          <a:p>
+            <a:r>
+              <a:t>向量经过L层Decoder Block：归一化、因果多头Attention、FFN与两条残差。</a:t>
+            </a:r>
+          </a:p>
+          <a:p>
+            <a:r>
+              <a:t>最终归一化和输出映射产生词表logits，选择下一ID并接回序列。</a:t>
+            </a:r>
+          </a:p>
+          <a:p>
+            <a:r>
+              <a:t>文本 → Tokenizer → IDs → Embedding → Decoder Blocks × L → Norm / LM Head → logits → 下一 token</a:t>
+            </a:r>
+          </a:p>
+          <a:p>
+            <a:r>
+              <a:t>沿用第一课后半段的Decoder-only文本生成架构。图中选择Pre-Norm和RoPE：h=x+MHA(Norm(x))，输出=h+FFN(Norm(h))，两条残差分别保留输入x和中间h。Q/K在Attention内使用RoPE；没有同时给输入叠加正弦PE。先沿左列读生成数据流，再展开右侧一个Block。说明B是batch、T是序列长度、D是隐藏维度、V是词表大小。生成时取最后位置的词表logits来选择下一ID，追加到ID序列；初始文本只需先分词，示意省略KV cache。原始Transformer是Encoder–Decoder，本课程沿用第一课选定的Decoder-only主线。第一课和第二课脚本只实现部分接口，图不是已训练模型的运行截图。</a:t>
             </a:r>
           </a:p>
           <a:p>
@@ -561,17 +561,17 @@
           </a:p>
           <a:p>
             <a:r>
-              <a:t>语言模型预测的是下一个 token；本课先解决文本怎样进入模型。</a:t>
-            </a:r>
-          </a:p>
-          <a:p>
-            <a:r>
-              <a:t>文本先按固定规则得到 ID；ID 再读取可训练参数，成为向量。</a:t>
-            </a:r>
-          </a:p>
-          <a:p>
-            <a:r>
-              <a:t>同一 ID 在不同位置仍读取同一行，因此还要让位置参与计算。</a:t>
+              <a:t>上节课把文字变数字、用Q/K算匹配并混合V，再从输出向量得到下一token候选概率。</a:t>
+            </a:r>
+          </a:p>
+          <a:p>
+            <a:r>
+              <a:t>把这些步骤放回完整生成架构：Tokenizer与Embedding在Block之前，Attention、FFN、Norm和残差在重复的Block中。</a:t>
+            </a:r>
+          </a:p>
+          <a:p>
+            <a:r>
+              <a:t>图中采用Pre-Norm与RoPE；向量在Block间保持[B,T,D]，输出投影变成[B,T,V]，生成时取最后位置。</a:t>
             </a:r>
           </a:p>
           <a:p>
@@ -2006,32 +2006,32 @@
           </a:p>
           <a:p>
             <a:r>
-              <a:t>词表规模是计算取舍，不只是“怎么分词”</a:t>
-            </a:r>
-          </a:p>
-          <a:p>
-            <a:r>
-              <a:t>V 增大，embedding 与输出层参数随之增大</a:t>
-            </a:r>
-          </a:p>
-          <a:p>
-            <a:r>
-              <a:t>T 增大，稠密注意力分数矩阵按 T² 增长</a:t>
-            </a:r>
-          </a:p>
-          <a:p>
-            <a:r>
-              <a:t>在覆盖、序列长度和参数规模之间权衡</a:t>
-            </a:r>
-          </a:p>
-          <a:p>
-            <a:r>
-              <a:t>E 的参数量 V×D；V=32768、D=4096、FP16 时约占 256 MiB。</a:t>
-            </a:r>
-          </a:p>
-          <a:p>
-            <a:r>
-              <a:t>只计算单个embedding矩阵，32768×4096×2字节=256MiB；未绑定的输出权重另占一份。注意力分数矩阵的T²描述稠密实现，不能说整个模型成本仅由T²决定；logits投影也有T×D×V成本。更大的词表不保证所有文本都更短，本页仅用手工切分比较粒度，不再讲词表320/384的数量对比。</a:t>
+              <a:t>衔接：今天细讲输入端的三个机制</a:t>
+            </a:r>
+          </a:p>
+          <a:p>
+            <a:r>
+              <a:t>回顾“我/喜欢/喝”的人工算例：匹配、混合与候选选择。</a:t>
+            </a:r>
+          </a:p>
+          <a:p>
+            <a:r>
+              <a:t>Tokenizer决定切出哪些片段；Embedding把ID映射成可训练向量。</a:t>
+            </a:r>
+          </a:p>
+          <a:p>
+            <a:r>
+              <a:t>位置编码提供位置关系：正弦PE可加在输入，RoPE则作用于Attention的Q/K。</a:t>
+            </a:r>
+          </a:p>
+          <a:p>
+            <a:r>
+              <a:t>本课：分词规则怎样学习 → ID怎样变成可训练向量 → 顺序怎样参与计算。</a:t>
+            </a:r>
+          </a:p>
+          <a:p>
+            <a:r>
+              <a:t>先用第一课代码的实际输出唤起记忆：注意力权重约[0.248,0.248,0.503]，混合向量约[0.752,0.752]，酒/牛奶概率约[0.680,0.320]。这些是人工参数的演示结果；显示值有四舍五入。区分第一次Softmax给输入位置分配混合权重，第二次给词表候选分配输出概率。再指向三个本课模块：第一课的text.split()替换为真实BPE，人工向量升级为Embedding参数及梯度，位置概念升级为正弦与RoPE机制。强调相加式PE和Q/K上的RoPE是不同接口，本课分别比较，不机械叠加。随后进入第3页奶茶BPE语料，先用一句话说明频繁片段可以合并，再按5/3/2手算统计。</a:t>
             </a:r>
           </a:p>
           <a:p>
@@ -2041,17 +2041,17 @@
           </a:p>
           <a:p>
             <a:r>
-              <a:t>按字：片段短、组合灵活，但同一段文本通常需要更多 token。</a:t>
-            </a:r>
-          </a:p>
-          <a:p>
-            <a:r>
-              <a:t>按整词：序列可能更短，但词表更大，新词也更难处理。</a:t>
-            </a:r>
-          </a:p>
-          <a:p>
-            <a:r>
-              <a:t>BPE 在基础单位之上合并常见片段，复用已有片段表示新组合。</a:t>
+              <a:t>第一课用空格切分和人工二维向量，走通了Q/K匹配、V加权混合与下一token选择。</a:t>
+            </a:r>
+          </a:p>
+          <a:p>
+            <a:r>
+              <a:t>本课依次补全输入端：BPE怎样学并执行切分规则；Embedding怎样查表、接受预测误差并更新参数。</a:t>
+            </a:r>
+          </a:p>
+          <a:p>
+            <a:r>
+              <a:t>位置编码说明顺序怎样进入运算：相加式PE作用于输入，RoPE作用于Q/K；二者作为不同接口讲解。</a:t>
             </a:r>
           </a:p>
           <a:p>
@@ -6538,7 +6538,7 @@
               </a:defRPr>
             </a:pPr>
             <a:r>
-              <a:t>文本怎样成为模型输入？</a:t>
+              <a:t>回顾：Transformer 的数据怎样流动？</a:t>
             </a:r>
           </a:p>
         </p:txBody>
@@ -6583,7 +6583,7 @@
               </a:defRPr>
             </a:pPr>
             <a:r>
-              <a:t>从真实文本出发，追踪 ID、可训练参数和位置三个接口。</a:t>
+              <a:t>沿用上节课的文本生成主线：Decoder-only，图中采用 Pre-Norm 与 RoPE。</a:t>
             </a:r>
           </a:p>
         </p:txBody>
@@ -6673,7 +6673,7 @@
               </a:defRPr>
             </a:pPr>
             <a:r>
-              <a:t>今天沿同一条链路，解释规则、参数和顺序。</a:t>
+              <a:t>文本变 ID，向量穿过多层 Block，最后得到下一 token 的概率。</a:t>
             </a:r>
           </a:p>
         </p:txBody>
@@ -6777,7 +6777,7 @@
         <p:spPr>
           <a:xfrm>
             <a:off x="548640" y="1901952"/>
-            <a:ext cx="6720840" cy="2926080"/>
+            <a:ext cx="4983480" cy="3803904"/>
           </a:xfrm>
           <a:prstGeom prst="roundRect">
             <a:avLst>
@@ -6822,7 +6822,7 @@
         <p:spPr>
           <a:xfrm>
             <a:off x="731520" y="2039112"/>
-            <a:ext cx="6355079" cy="283464"/>
+            <a:ext cx="4617720" cy="283464"/>
           </a:xfrm>
           <a:prstGeom prst="rect">
             <a:avLst/>
@@ -6853,21 +6853,1001 @@
               </a:defRPr>
             </a:pPr>
             <a:r>
-              <a:t>例子：把“我喜欢喝牛奶。”送进模型</a:t>
-            </a:r>
-          </a:p>
-        </p:txBody>
-      </p:sp>
-      <p:sp>
-        <p:nvSpPr>
-          <p:cNvPr id="18" name="TextBox 17"/>
-          <p:cNvSpPr txBox="1"/>
-          <p:nvPr/>
-        </p:nvSpPr>
-        <p:spPr>
-          <a:xfrm>
-            <a:off x="786384" y="2423160"/>
-            <a:ext cx="2011680" cy="340868"/>
+              <a:t>生成数据流：每轮预测一个新 token</a:t>
+            </a:r>
+          </a:p>
+        </p:txBody>
+      </p:sp>
+      <p:sp>
+        <p:nvSpPr>
+          <p:cNvPr id="18" name="Rounded Rectangle 17"/>
+          <p:cNvSpPr/>
+          <p:nvPr/>
+        </p:nvSpPr>
+        <p:spPr>
+          <a:xfrm>
+            <a:off x="896112" y="2423160"/>
+            <a:ext cx="4352544" cy="438912"/>
+          </a:xfrm>
+          <a:prstGeom prst="roundRect">
+            <a:avLst>
+              <a:gd name="adj" fmla="val 6000"/>
+            </a:avLst>
+          </a:prstGeom>
+          <a:solidFill>
+            <a:srgbClr val="E8F0FC"/>
+          </a:solidFill>
+          <a:ln>
+            <a:noFill/>
+          </a:ln>
+        </p:spPr>
+        <p:style>
+          <a:lnRef idx="1">
+            <a:schemeClr val="accent1"/>
+          </a:lnRef>
+          <a:fillRef idx="3">
+            <a:schemeClr val="accent1"/>
+          </a:fillRef>
+          <a:effectRef idx="2">
+            <a:schemeClr val="accent1"/>
+          </a:effectRef>
+          <a:fontRef idx="minor">
+            <a:schemeClr val="lt1"/>
+          </a:fontRef>
+        </p:style>
+        <p:txBody>
+          <a:bodyPr rtlCol="0" anchor="ctr"/>
+          <a:lstStyle/>
+          <a:p>
+            <a:pPr algn="ctr"/>
+          </a:p>
+        </p:txBody>
+      </p:sp>
+      <p:sp>
+        <p:nvSpPr>
+          <p:cNvPr id="19" name="TextBox 18"/>
+          <p:cNvSpPr txBox="1"/>
+          <p:nvPr/>
+        </p:nvSpPr>
+        <p:spPr>
+          <a:xfrm>
+            <a:off x="978408" y="2496312"/>
+            <a:ext cx="4187952" cy="320040"/>
+          </a:xfrm>
+          <a:prstGeom prst="rect">
+            <a:avLst/>
+          </a:prstGeom>
+          <a:noFill/>
+        </p:spPr>
+        <p:txBody>
+          <a:bodyPr wrap="none" lIns="0" rIns="0" tIns="0" bIns="0">
+            <a:spAutoFit/>
+          </a:bodyPr>
+          <a:lstStyle/>
+          <a:p>
+            <a:pPr algn="ctr">
+              <a:lnSpc>
+                <a:spcPts val="2196"/>
+              </a:lnSpc>
+              <a:spcBef>
+                <a:spcPts val="0"/>
+              </a:spcBef>
+              <a:spcAft>
+                <a:spcPts val="0"/>
+              </a:spcAft>
+              <a:defRPr sz="1800" b="0">
+                <a:solidFill>
+                  <a:srgbClr val="2458C6"/>
+                </a:solidFill>
+                <a:latin typeface="Arial Unicode MS"/>
+              </a:defRPr>
+            </a:pPr>
+            <a:r>
+              <a:t>文本 → Tokenizer → IDs [B,T]</a:t>
+            </a:r>
+          </a:p>
+        </p:txBody>
+      </p:sp>
+      <p:cxnSp>
+        <p:nvCxnSpPr>
+          <p:cNvPr id="20" name="Connector 19"/>
+          <p:cNvCxnSpPr/>
+          <p:nvPr/>
+        </p:nvCxnSpPr>
+        <p:spPr>
+          <a:xfrm>
+            <a:off x="3072384" y="2871215"/>
+            <a:ext cx="0" cy="118873"/>
+          </a:xfrm>
+          <a:prstGeom prst="line">
+            <a:avLst/>
+          </a:prstGeom>
+          <a:ln w="21590">
+            <a:solidFill>
+              <a:srgbClr val="087F8C"/>
+            </a:solidFill>
+          </a:ln>
+        </p:spPr>
+        <p:style>
+          <a:lnRef idx="2">
+            <a:schemeClr val="accent1"/>
+          </a:lnRef>
+          <a:fillRef idx="0">
+            <a:schemeClr val="accent1"/>
+          </a:fillRef>
+          <a:effectRef idx="1">
+            <a:schemeClr val="accent1"/>
+          </a:effectRef>
+          <a:fontRef idx="minor">
+            <a:schemeClr val="tx1"/>
+          </a:fontRef>
+        </p:style>
+      </p:cxnSp>
+      <p:sp>
+        <p:nvSpPr>
+          <p:cNvPr id="21" name="Isosceles Triangle 20"/>
+          <p:cNvSpPr/>
+          <p:nvPr/>
+        </p:nvSpPr>
+        <p:spPr>
+          <a:xfrm rot="10800000">
+            <a:off x="3040379" y="2948940"/>
+            <a:ext cx="64008" cy="82296"/>
+          </a:xfrm>
+          <a:prstGeom prst="triangle">
+            <a:avLst/>
+          </a:prstGeom>
+          <a:solidFill>
+            <a:srgbClr val="087F8C"/>
+          </a:solidFill>
+          <a:ln>
+            <a:noFill/>
+          </a:ln>
+        </p:spPr>
+        <p:style>
+          <a:lnRef idx="1">
+            <a:schemeClr val="accent1"/>
+          </a:lnRef>
+          <a:fillRef idx="3">
+            <a:schemeClr val="accent1"/>
+          </a:fillRef>
+          <a:effectRef idx="2">
+            <a:schemeClr val="accent1"/>
+          </a:effectRef>
+          <a:fontRef idx="minor">
+            <a:schemeClr val="lt1"/>
+          </a:fontRef>
+        </p:style>
+        <p:txBody>
+          <a:bodyPr rtlCol="0" anchor="ctr"/>
+          <a:lstStyle/>
+          <a:p>
+            <a:pPr algn="ctr"/>
+          </a:p>
+        </p:txBody>
+      </p:sp>
+      <p:sp>
+        <p:nvSpPr>
+          <p:cNvPr id="22" name="Rounded Rectangle 21"/>
+          <p:cNvSpPr/>
+          <p:nvPr/>
+        </p:nvSpPr>
+        <p:spPr>
+          <a:xfrm>
+            <a:off x="896112" y="3008376"/>
+            <a:ext cx="4352544" cy="438912"/>
+          </a:xfrm>
+          <a:prstGeom prst="roundRect">
+            <a:avLst>
+              <a:gd name="adj" fmla="val 6000"/>
+            </a:avLst>
+          </a:prstGeom>
+          <a:solidFill>
+            <a:srgbClr val="E8F0FC"/>
+          </a:solidFill>
+          <a:ln>
+            <a:noFill/>
+          </a:ln>
+        </p:spPr>
+        <p:style>
+          <a:lnRef idx="1">
+            <a:schemeClr val="accent1"/>
+          </a:lnRef>
+          <a:fillRef idx="3">
+            <a:schemeClr val="accent1"/>
+          </a:fillRef>
+          <a:effectRef idx="2">
+            <a:schemeClr val="accent1"/>
+          </a:effectRef>
+          <a:fontRef idx="minor">
+            <a:schemeClr val="lt1"/>
+          </a:fontRef>
+        </p:style>
+        <p:txBody>
+          <a:bodyPr rtlCol="0" anchor="ctr"/>
+          <a:lstStyle/>
+          <a:p>
+            <a:pPr algn="ctr"/>
+          </a:p>
+        </p:txBody>
+      </p:sp>
+      <p:sp>
+        <p:nvSpPr>
+          <p:cNvPr id="23" name="TextBox 22"/>
+          <p:cNvSpPr txBox="1"/>
+          <p:nvPr/>
+        </p:nvSpPr>
+        <p:spPr>
+          <a:xfrm>
+            <a:off x="978408" y="3081528"/>
+            <a:ext cx="4187952" cy="320040"/>
+          </a:xfrm>
+          <a:prstGeom prst="rect">
+            <a:avLst/>
+          </a:prstGeom>
+          <a:noFill/>
+        </p:spPr>
+        <p:txBody>
+          <a:bodyPr wrap="none" lIns="0" rIns="0" tIns="0" bIns="0">
+            <a:spAutoFit/>
+          </a:bodyPr>
+          <a:lstStyle/>
+          <a:p>
+            <a:pPr algn="ctr">
+              <a:lnSpc>
+                <a:spcPts val="2196"/>
+              </a:lnSpc>
+              <a:spcBef>
+                <a:spcPts val="0"/>
+              </a:spcBef>
+              <a:spcAft>
+                <a:spcPts val="0"/>
+              </a:spcAft>
+              <a:defRPr sz="1800" b="0">
+                <a:solidFill>
+                  <a:srgbClr val="2458C6"/>
+                </a:solidFill>
+                <a:latin typeface="Arial Unicode MS"/>
+              </a:defRPr>
+            </a:pPr>
+            <a:r>
+              <a:t>Embedding → X [B,T,D]</a:t>
+            </a:r>
+          </a:p>
+        </p:txBody>
+      </p:sp>
+      <p:cxnSp>
+        <p:nvCxnSpPr>
+          <p:cNvPr id="24" name="Connector 23"/>
+          <p:cNvCxnSpPr/>
+          <p:nvPr/>
+        </p:nvCxnSpPr>
+        <p:spPr>
+          <a:xfrm>
+            <a:off x="3072384" y="3456432"/>
+            <a:ext cx="0" cy="118872"/>
+          </a:xfrm>
+          <a:prstGeom prst="line">
+            <a:avLst/>
+          </a:prstGeom>
+          <a:ln w="21590">
+            <a:solidFill>
+              <a:srgbClr val="087F8C"/>
+            </a:solidFill>
+          </a:ln>
+        </p:spPr>
+        <p:style>
+          <a:lnRef idx="2">
+            <a:schemeClr val="accent1"/>
+          </a:lnRef>
+          <a:fillRef idx="0">
+            <a:schemeClr val="accent1"/>
+          </a:fillRef>
+          <a:effectRef idx="1">
+            <a:schemeClr val="accent1"/>
+          </a:effectRef>
+          <a:fontRef idx="minor">
+            <a:schemeClr val="tx1"/>
+          </a:fontRef>
+        </p:style>
+      </p:cxnSp>
+      <p:sp>
+        <p:nvSpPr>
+          <p:cNvPr id="25" name="Isosceles Triangle 24"/>
+          <p:cNvSpPr/>
+          <p:nvPr/>
+        </p:nvSpPr>
+        <p:spPr>
+          <a:xfrm rot="10800000">
+            <a:off x="3040379" y="3534156"/>
+            <a:ext cx="64008" cy="82296"/>
+          </a:xfrm>
+          <a:prstGeom prst="triangle">
+            <a:avLst/>
+          </a:prstGeom>
+          <a:solidFill>
+            <a:srgbClr val="087F8C"/>
+          </a:solidFill>
+          <a:ln>
+            <a:noFill/>
+          </a:ln>
+        </p:spPr>
+        <p:style>
+          <a:lnRef idx="1">
+            <a:schemeClr val="accent1"/>
+          </a:lnRef>
+          <a:fillRef idx="3">
+            <a:schemeClr val="accent1"/>
+          </a:fillRef>
+          <a:effectRef idx="2">
+            <a:schemeClr val="accent1"/>
+          </a:effectRef>
+          <a:fontRef idx="minor">
+            <a:schemeClr val="lt1"/>
+          </a:fontRef>
+        </p:style>
+        <p:txBody>
+          <a:bodyPr rtlCol="0" anchor="ctr"/>
+          <a:lstStyle/>
+          <a:p>
+            <a:pPr algn="ctr"/>
+          </a:p>
+        </p:txBody>
+      </p:sp>
+      <p:sp>
+        <p:nvSpPr>
+          <p:cNvPr id="26" name="Rounded Rectangle 25"/>
+          <p:cNvSpPr/>
+          <p:nvPr/>
+        </p:nvSpPr>
+        <p:spPr>
+          <a:xfrm>
+            <a:off x="896112" y="3593591"/>
+            <a:ext cx="4352544" cy="438912"/>
+          </a:xfrm>
+          <a:prstGeom prst="roundRect">
+            <a:avLst>
+              <a:gd name="adj" fmla="val 6000"/>
+            </a:avLst>
+          </a:prstGeom>
+          <a:solidFill>
+            <a:srgbClr val="DFF0ED"/>
+          </a:solidFill>
+          <a:ln>
+            <a:noFill/>
+          </a:ln>
+        </p:spPr>
+        <p:style>
+          <a:lnRef idx="1">
+            <a:schemeClr val="accent1"/>
+          </a:lnRef>
+          <a:fillRef idx="3">
+            <a:schemeClr val="accent1"/>
+          </a:fillRef>
+          <a:effectRef idx="2">
+            <a:schemeClr val="accent1"/>
+          </a:effectRef>
+          <a:fontRef idx="minor">
+            <a:schemeClr val="lt1"/>
+          </a:fontRef>
+        </p:style>
+        <p:txBody>
+          <a:bodyPr rtlCol="0" anchor="ctr"/>
+          <a:lstStyle/>
+          <a:p>
+            <a:pPr algn="ctr"/>
+          </a:p>
+        </p:txBody>
+      </p:sp>
+      <p:sp>
+        <p:nvSpPr>
+          <p:cNvPr id="27" name="TextBox 26"/>
+          <p:cNvSpPr txBox="1"/>
+          <p:nvPr/>
+        </p:nvSpPr>
+        <p:spPr>
+          <a:xfrm>
+            <a:off x="978408" y="3666744"/>
+            <a:ext cx="4187952" cy="320040"/>
+          </a:xfrm>
+          <a:prstGeom prst="rect">
+            <a:avLst/>
+          </a:prstGeom>
+          <a:noFill/>
+        </p:spPr>
+        <p:txBody>
+          <a:bodyPr wrap="none" lIns="0" rIns="0" tIns="0" bIns="0">
+            <a:spAutoFit/>
+          </a:bodyPr>
+          <a:lstStyle/>
+          <a:p>
+            <a:pPr algn="ctr">
+              <a:lnSpc>
+                <a:spcPts val="2196"/>
+              </a:lnSpc>
+              <a:spcBef>
+                <a:spcPts val="0"/>
+              </a:spcBef>
+              <a:spcAft>
+                <a:spcPts val="0"/>
+              </a:spcAft>
+              <a:defRPr sz="1800" b="0">
+                <a:solidFill>
+                  <a:srgbClr val="087568"/>
+                </a:solidFill>
+                <a:latin typeface="Arial Unicode MS"/>
+              </a:defRPr>
+            </a:pPr>
+            <a:r>
+              <a:t>Decoder Block × L → H [B,T,D]</a:t>
+            </a:r>
+          </a:p>
+        </p:txBody>
+      </p:sp>
+      <p:cxnSp>
+        <p:nvCxnSpPr>
+          <p:cNvPr id="28" name="Connector 27"/>
+          <p:cNvCxnSpPr/>
+          <p:nvPr/>
+        </p:nvCxnSpPr>
+        <p:spPr>
+          <a:xfrm>
+            <a:off x="3072384" y="4041648"/>
+            <a:ext cx="0" cy="118872"/>
+          </a:xfrm>
+          <a:prstGeom prst="line">
+            <a:avLst/>
+          </a:prstGeom>
+          <a:ln w="21590">
+            <a:solidFill>
+              <a:srgbClr val="087F8C"/>
+            </a:solidFill>
+          </a:ln>
+        </p:spPr>
+        <p:style>
+          <a:lnRef idx="2">
+            <a:schemeClr val="accent1"/>
+          </a:lnRef>
+          <a:fillRef idx="0">
+            <a:schemeClr val="accent1"/>
+          </a:fillRef>
+          <a:effectRef idx="1">
+            <a:schemeClr val="accent1"/>
+          </a:effectRef>
+          <a:fontRef idx="minor">
+            <a:schemeClr val="tx1"/>
+          </a:fontRef>
+        </p:style>
+      </p:cxnSp>
+      <p:sp>
+        <p:nvSpPr>
+          <p:cNvPr id="29" name="Isosceles Triangle 28"/>
+          <p:cNvSpPr/>
+          <p:nvPr/>
+        </p:nvSpPr>
+        <p:spPr>
+          <a:xfrm rot="10800000">
+            <a:off x="3040379" y="4119372"/>
+            <a:ext cx="64008" cy="82296"/>
+          </a:xfrm>
+          <a:prstGeom prst="triangle">
+            <a:avLst/>
+          </a:prstGeom>
+          <a:solidFill>
+            <a:srgbClr val="087F8C"/>
+          </a:solidFill>
+          <a:ln>
+            <a:noFill/>
+          </a:ln>
+        </p:spPr>
+        <p:style>
+          <a:lnRef idx="1">
+            <a:schemeClr val="accent1"/>
+          </a:lnRef>
+          <a:fillRef idx="3">
+            <a:schemeClr val="accent1"/>
+          </a:fillRef>
+          <a:effectRef idx="2">
+            <a:schemeClr val="accent1"/>
+          </a:effectRef>
+          <a:fontRef idx="minor">
+            <a:schemeClr val="lt1"/>
+          </a:fontRef>
+        </p:style>
+        <p:txBody>
+          <a:bodyPr rtlCol="0" anchor="ctr"/>
+          <a:lstStyle/>
+          <a:p>
+            <a:pPr algn="ctr"/>
+          </a:p>
+        </p:txBody>
+      </p:sp>
+      <p:sp>
+        <p:nvSpPr>
+          <p:cNvPr id="30" name="Rounded Rectangle 29"/>
+          <p:cNvSpPr/>
+          <p:nvPr/>
+        </p:nvSpPr>
+        <p:spPr>
+          <a:xfrm>
+            <a:off x="896112" y="4178808"/>
+            <a:ext cx="4352544" cy="438912"/>
+          </a:xfrm>
+          <a:prstGeom prst="roundRect">
+            <a:avLst>
+              <a:gd name="adj" fmla="val 6000"/>
+            </a:avLst>
+          </a:prstGeom>
+          <a:solidFill>
+            <a:srgbClr val="E8F0FC"/>
+          </a:solidFill>
+          <a:ln>
+            <a:noFill/>
+          </a:ln>
+        </p:spPr>
+        <p:style>
+          <a:lnRef idx="1">
+            <a:schemeClr val="accent1"/>
+          </a:lnRef>
+          <a:fillRef idx="3">
+            <a:schemeClr val="accent1"/>
+          </a:fillRef>
+          <a:effectRef idx="2">
+            <a:schemeClr val="accent1"/>
+          </a:effectRef>
+          <a:fontRef idx="minor">
+            <a:schemeClr val="lt1"/>
+          </a:fontRef>
+        </p:style>
+        <p:txBody>
+          <a:bodyPr rtlCol="0" anchor="ctr"/>
+          <a:lstStyle/>
+          <a:p>
+            <a:pPr algn="ctr"/>
+          </a:p>
+        </p:txBody>
+      </p:sp>
+      <p:sp>
+        <p:nvSpPr>
+          <p:cNvPr id="31" name="TextBox 30"/>
+          <p:cNvSpPr txBox="1"/>
+          <p:nvPr/>
+        </p:nvSpPr>
+        <p:spPr>
+          <a:xfrm>
+            <a:off x="978408" y="4251960"/>
+            <a:ext cx="4187952" cy="320040"/>
+          </a:xfrm>
+          <a:prstGeom prst="rect">
+            <a:avLst/>
+          </a:prstGeom>
+          <a:noFill/>
+        </p:spPr>
+        <p:txBody>
+          <a:bodyPr wrap="none" lIns="0" rIns="0" tIns="0" bIns="0">
+            <a:spAutoFit/>
+          </a:bodyPr>
+          <a:lstStyle/>
+          <a:p>
+            <a:pPr algn="ctr">
+              <a:lnSpc>
+                <a:spcPts val="2196"/>
+              </a:lnSpc>
+              <a:spcBef>
+                <a:spcPts val="0"/>
+              </a:spcBef>
+              <a:spcAft>
+                <a:spcPts val="0"/>
+              </a:spcAft>
+              <a:defRPr sz="1800" b="0">
+                <a:solidFill>
+                  <a:srgbClr val="2458C6"/>
+                </a:solidFill>
+                <a:latin typeface="Arial Unicode MS"/>
+              </a:defRPr>
+            </a:pPr>
+            <a:r>
+              <a:t>Norm + LM Head → logits [B,T,V]</a:t>
+            </a:r>
+          </a:p>
+        </p:txBody>
+      </p:sp>
+      <p:cxnSp>
+        <p:nvCxnSpPr>
+          <p:cNvPr id="32" name="Connector 31"/>
+          <p:cNvCxnSpPr/>
+          <p:nvPr/>
+        </p:nvCxnSpPr>
+        <p:spPr>
+          <a:xfrm>
+            <a:off x="3072384" y="4626864"/>
+            <a:ext cx="0" cy="118872"/>
+          </a:xfrm>
+          <a:prstGeom prst="line">
+            <a:avLst/>
+          </a:prstGeom>
+          <a:ln w="21590">
+            <a:solidFill>
+              <a:srgbClr val="087F8C"/>
+            </a:solidFill>
+          </a:ln>
+        </p:spPr>
+        <p:style>
+          <a:lnRef idx="2">
+            <a:schemeClr val="accent1"/>
+          </a:lnRef>
+          <a:fillRef idx="0">
+            <a:schemeClr val="accent1"/>
+          </a:fillRef>
+          <a:effectRef idx="1">
+            <a:schemeClr val="accent1"/>
+          </a:effectRef>
+          <a:fontRef idx="minor">
+            <a:schemeClr val="tx1"/>
+          </a:fontRef>
+        </p:style>
+      </p:cxnSp>
+      <p:sp>
+        <p:nvSpPr>
+          <p:cNvPr id="33" name="Isosceles Triangle 32"/>
+          <p:cNvSpPr/>
+          <p:nvPr/>
+        </p:nvSpPr>
+        <p:spPr>
+          <a:xfrm rot="10800000">
+            <a:off x="3040379" y="4704588"/>
+            <a:ext cx="64008" cy="82296"/>
+          </a:xfrm>
+          <a:prstGeom prst="triangle">
+            <a:avLst/>
+          </a:prstGeom>
+          <a:solidFill>
+            <a:srgbClr val="087F8C"/>
+          </a:solidFill>
+          <a:ln>
+            <a:noFill/>
+          </a:ln>
+        </p:spPr>
+        <p:style>
+          <a:lnRef idx="1">
+            <a:schemeClr val="accent1"/>
+          </a:lnRef>
+          <a:fillRef idx="3">
+            <a:schemeClr val="accent1"/>
+          </a:fillRef>
+          <a:effectRef idx="2">
+            <a:schemeClr val="accent1"/>
+          </a:effectRef>
+          <a:fontRef idx="minor">
+            <a:schemeClr val="lt1"/>
+          </a:fontRef>
+        </p:style>
+        <p:txBody>
+          <a:bodyPr rtlCol="0" anchor="ctr"/>
+          <a:lstStyle/>
+          <a:p>
+            <a:pPr algn="ctr"/>
+          </a:p>
+        </p:txBody>
+      </p:sp>
+      <p:sp>
+        <p:nvSpPr>
+          <p:cNvPr id="34" name="Rounded Rectangle 33"/>
+          <p:cNvSpPr/>
+          <p:nvPr/>
+        </p:nvSpPr>
+        <p:spPr>
+          <a:xfrm>
+            <a:off x="896112" y="4764024"/>
+            <a:ext cx="4352544" cy="438912"/>
+          </a:xfrm>
+          <a:prstGeom prst="roundRect">
+            <a:avLst>
+              <a:gd name="adj" fmla="val 6000"/>
+            </a:avLst>
+          </a:prstGeom>
+          <a:solidFill>
+            <a:srgbClr val="E8F0FC"/>
+          </a:solidFill>
+          <a:ln>
+            <a:noFill/>
+          </a:ln>
+        </p:spPr>
+        <p:style>
+          <a:lnRef idx="1">
+            <a:schemeClr val="accent1"/>
+          </a:lnRef>
+          <a:fillRef idx="3">
+            <a:schemeClr val="accent1"/>
+          </a:fillRef>
+          <a:effectRef idx="2">
+            <a:schemeClr val="accent1"/>
+          </a:effectRef>
+          <a:fontRef idx="minor">
+            <a:schemeClr val="lt1"/>
+          </a:fontRef>
+        </p:style>
+        <p:txBody>
+          <a:bodyPr rtlCol="0" anchor="ctr"/>
+          <a:lstStyle/>
+          <a:p>
+            <a:pPr algn="ctr"/>
+          </a:p>
+        </p:txBody>
+      </p:sp>
+      <p:sp>
+        <p:nvSpPr>
+          <p:cNvPr id="35" name="TextBox 34"/>
+          <p:cNvSpPr txBox="1"/>
+          <p:nvPr/>
+        </p:nvSpPr>
+        <p:spPr>
+          <a:xfrm>
+            <a:off x="978408" y="4837176"/>
+            <a:ext cx="4187952" cy="320040"/>
+          </a:xfrm>
+          <a:prstGeom prst="rect">
+            <a:avLst/>
+          </a:prstGeom>
+          <a:noFill/>
+        </p:spPr>
+        <p:txBody>
+          <a:bodyPr wrap="none" lIns="0" rIns="0" tIns="0" bIns="0">
+            <a:spAutoFit/>
+          </a:bodyPr>
+          <a:lstStyle/>
+          <a:p>
+            <a:pPr algn="ctr">
+              <a:lnSpc>
+                <a:spcPts val="2196"/>
+              </a:lnSpc>
+              <a:spcBef>
+                <a:spcPts val="0"/>
+              </a:spcBef>
+              <a:spcAft>
+                <a:spcPts val="0"/>
+              </a:spcAft>
+              <a:defRPr sz="1800" b="0">
+                <a:solidFill>
+                  <a:srgbClr val="2458C6"/>
+                </a:solidFill>
+                <a:latin typeface="Arial Unicode MS"/>
+              </a:defRPr>
+            </a:pPr>
+            <a:r>
+              <a:t>最后位置：Softmax → 选下一 token</a:t>
+            </a:r>
+          </a:p>
+        </p:txBody>
+      </p:sp>
+      <p:cxnSp>
+        <p:nvCxnSpPr>
+          <p:cNvPr id="36" name="Connector 35"/>
+          <p:cNvCxnSpPr/>
+          <p:nvPr/>
+        </p:nvCxnSpPr>
+        <p:spPr>
+          <a:xfrm>
+            <a:off x="3072384" y="5212080"/>
+            <a:ext cx="0" cy="228600"/>
+          </a:xfrm>
+          <a:prstGeom prst="line">
+            <a:avLst/>
+          </a:prstGeom>
+          <a:ln w="21590">
+            <a:solidFill>
+              <a:srgbClr val="087F8C"/>
+            </a:solidFill>
+          </a:ln>
+        </p:spPr>
+        <p:style>
+          <a:lnRef idx="2">
+            <a:schemeClr val="accent1"/>
+          </a:lnRef>
+          <a:fillRef idx="0">
+            <a:schemeClr val="accent1"/>
+          </a:fillRef>
+          <a:effectRef idx="1">
+            <a:schemeClr val="accent1"/>
+          </a:effectRef>
+          <a:fontRef idx="minor">
+            <a:schemeClr val="tx1"/>
+          </a:fontRef>
+        </p:style>
+      </p:cxnSp>
+      <p:cxnSp>
+        <p:nvCxnSpPr>
+          <p:cNvPr id="37" name="Connector 36"/>
+          <p:cNvCxnSpPr/>
+          <p:nvPr/>
+        </p:nvCxnSpPr>
+        <p:spPr>
+          <a:xfrm flipH="1">
+            <a:off x="722376" y="5440680"/>
+            <a:ext cx="2350008" cy="0"/>
+          </a:xfrm>
+          <a:prstGeom prst="line">
+            <a:avLst/>
+          </a:prstGeom>
+          <a:ln w="21590">
+            <a:solidFill>
+              <a:srgbClr val="087F8C"/>
+            </a:solidFill>
+          </a:ln>
+        </p:spPr>
+        <p:style>
+          <a:lnRef idx="2">
+            <a:schemeClr val="accent1"/>
+          </a:lnRef>
+          <a:fillRef idx="0">
+            <a:schemeClr val="accent1"/>
+          </a:fillRef>
+          <a:effectRef idx="1">
+            <a:schemeClr val="accent1"/>
+          </a:effectRef>
+          <a:fontRef idx="minor">
+            <a:schemeClr val="tx1"/>
+          </a:fontRef>
+        </p:style>
+      </p:cxnSp>
+      <p:cxnSp>
+        <p:nvCxnSpPr>
+          <p:cNvPr id="38" name="Connector 37"/>
+          <p:cNvCxnSpPr/>
+          <p:nvPr/>
+        </p:nvCxnSpPr>
+        <p:spPr>
+          <a:xfrm flipV="1">
+            <a:off x="722376" y="2350008"/>
+            <a:ext cx="0" cy="3090672"/>
+          </a:xfrm>
+          <a:prstGeom prst="line">
+            <a:avLst/>
+          </a:prstGeom>
+          <a:ln w="21590">
+            <a:solidFill>
+              <a:srgbClr val="087F8C"/>
+            </a:solidFill>
+          </a:ln>
+        </p:spPr>
+        <p:style>
+          <a:lnRef idx="2">
+            <a:schemeClr val="accent1"/>
+          </a:lnRef>
+          <a:fillRef idx="0">
+            <a:schemeClr val="accent1"/>
+          </a:fillRef>
+          <a:effectRef idx="1">
+            <a:schemeClr val="accent1"/>
+          </a:effectRef>
+          <a:fontRef idx="minor">
+            <a:schemeClr val="tx1"/>
+          </a:fontRef>
+        </p:style>
+      </p:cxnSp>
+      <p:cxnSp>
+        <p:nvCxnSpPr>
+          <p:cNvPr id="39" name="Connector 38"/>
+          <p:cNvCxnSpPr/>
+          <p:nvPr/>
+        </p:nvCxnSpPr>
+        <p:spPr>
+          <a:xfrm>
+            <a:off x="722376" y="2350008"/>
+            <a:ext cx="3959352" cy="0"/>
+          </a:xfrm>
+          <a:prstGeom prst="line">
+            <a:avLst/>
+          </a:prstGeom>
+          <a:ln w="21590">
+            <a:solidFill>
+              <a:srgbClr val="087F8C"/>
+            </a:solidFill>
+          </a:ln>
+        </p:spPr>
+        <p:style>
+          <a:lnRef idx="2">
+            <a:schemeClr val="accent1"/>
+          </a:lnRef>
+          <a:fillRef idx="0">
+            <a:schemeClr val="accent1"/>
+          </a:fillRef>
+          <a:effectRef idx="1">
+            <a:schemeClr val="accent1"/>
+          </a:effectRef>
+          <a:fontRef idx="minor">
+            <a:schemeClr val="tx1"/>
+          </a:fontRef>
+        </p:style>
+      </p:cxnSp>
+      <p:cxnSp>
+        <p:nvCxnSpPr>
+          <p:cNvPr id="40" name="Connector 39"/>
+          <p:cNvCxnSpPr/>
+          <p:nvPr/>
+        </p:nvCxnSpPr>
+        <p:spPr>
+          <a:xfrm>
+            <a:off x="4681728" y="2350008"/>
+            <a:ext cx="0" cy="54864"/>
+          </a:xfrm>
+          <a:prstGeom prst="line">
+            <a:avLst/>
+          </a:prstGeom>
+          <a:ln w="21590">
+            <a:solidFill>
+              <a:srgbClr val="087F8C"/>
+            </a:solidFill>
+          </a:ln>
+        </p:spPr>
+        <p:style>
+          <a:lnRef idx="2">
+            <a:schemeClr val="accent1"/>
+          </a:lnRef>
+          <a:fillRef idx="0">
+            <a:schemeClr val="accent1"/>
+          </a:fillRef>
+          <a:effectRef idx="1">
+            <a:schemeClr val="accent1"/>
+          </a:effectRef>
+          <a:fontRef idx="minor">
+            <a:schemeClr val="tx1"/>
+          </a:fontRef>
+        </p:style>
+      </p:cxnSp>
+      <p:sp>
+        <p:nvSpPr>
+          <p:cNvPr id="41" name="Isosceles Triangle 40"/>
+          <p:cNvSpPr/>
+          <p:nvPr/>
+        </p:nvSpPr>
+        <p:spPr>
+          <a:xfrm rot="10800000">
+            <a:off x="4649724" y="2363724"/>
+            <a:ext cx="64008" cy="82296"/>
+          </a:xfrm>
+          <a:prstGeom prst="triangle">
+            <a:avLst/>
+          </a:prstGeom>
+          <a:solidFill>
+            <a:srgbClr val="087F8C"/>
+          </a:solidFill>
+          <a:ln>
+            <a:noFill/>
+          </a:ln>
+        </p:spPr>
+        <p:style>
+          <a:lnRef idx="1">
+            <a:schemeClr val="accent1"/>
+          </a:lnRef>
+          <a:fillRef idx="3">
+            <a:schemeClr val="accent1"/>
+          </a:fillRef>
+          <a:effectRef idx="2">
+            <a:schemeClr val="accent1"/>
+          </a:effectRef>
+          <a:fontRef idx="minor">
+            <a:schemeClr val="lt1"/>
+          </a:fontRef>
+        </p:style>
+        <p:txBody>
+          <a:bodyPr rtlCol="0" anchor="ctr"/>
+          <a:lstStyle/>
+          <a:p>
+            <a:pPr algn="ctr"/>
+          </a:p>
+        </p:txBody>
+      </p:sp>
+      <p:sp>
+        <p:nvSpPr>
+          <p:cNvPr id="42" name="TextBox 41"/>
+          <p:cNvSpPr txBox="1"/>
+          <p:nvPr/>
+        </p:nvSpPr>
+        <p:spPr>
+          <a:xfrm>
+            <a:off x="1069848" y="5486400"/>
+            <a:ext cx="3977639" cy="283464"/>
           </a:xfrm>
           <a:prstGeom prst="rect">
             <a:avLst/>
@@ -6882,96 +7862,6 @@
           <a:p>
             <a:pPr>
               <a:lnSpc>
-                <a:spcPts val="2684"/>
-              </a:lnSpc>
-              <a:spcBef>
-                <a:spcPts val="0"/>
-              </a:spcBef>
-              <a:spcAft>
-                <a:spcPts val="0"/>
-              </a:spcAft>
-              <a:defRPr sz="2200" b="1">
-                <a:solidFill>
-                  <a:srgbClr val="2458C6"/>
-                </a:solidFill>
-                <a:latin typeface="Arial Unicode MS"/>
-              </a:defRPr>
-            </a:pPr>
-            <a:r>
-              <a:t>文本 → ID</a:t>
-            </a:r>
-          </a:p>
-        </p:txBody>
-      </p:sp>
-      <p:sp>
-        <p:nvSpPr>
-          <p:cNvPr id="19" name="TextBox 18"/>
-          <p:cNvSpPr txBox="1"/>
-          <p:nvPr/>
-        </p:nvSpPr>
-        <p:spPr>
-          <a:xfrm>
-            <a:off x="2761488" y="2423160"/>
-            <a:ext cx="4160520" cy="338328"/>
-          </a:xfrm>
-          <a:prstGeom prst="rect">
-            <a:avLst/>
-          </a:prstGeom>
-          <a:noFill/>
-        </p:spPr>
-        <p:txBody>
-          <a:bodyPr wrap="none" lIns="0" rIns="0" tIns="0" bIns="0">
-            <a:spAutoFit/>
-          </a:bodyPr>
-          <a:lstStyle/>
-          <a:p>
-            <a:pPr>
-              <a:lnSpc>
-                <a:spcPts val="2440"/>
-              </a:lnSpc>
-              <a:spcBef>
-                <a:spcPts val="0"/>
-              </a:spcBef>
-              <a:spcAft>
-                <a:spcPts val="0"/>
-              </a:spcAft>
-              <a:defRPr sz="2000" b="0">
-                <a:solidFill>
-                  <a:srgbClr val="14263D"/>
-                </a:solidFill>
-                <a:latin typeface="Arial Unicode MS"/>
-              </a:defRPr>
-            </a:pPr>
-            <a:r>
-              <a:t>[300,304,262]</a:t>
-            </a:r>
-          </a:p>
-        </p:txBody>
-      </p:sp>
-      <p:sp>
-        <p:nvSpPr>
-          <p:cNvPr id="20" name="TextBox 19"/>
-          <p:cNvSpPr txBox="1"/>
-          <p:nvPr/>
-        </p:nvSpPr>
-        <p:spPr>
-          <a:xfrm>
-            <a:off x="2761488" y="2752344"/>
-            <a:ext cx="4160520" cy="292608"/>
-          </a:xfrm>
-          <a:prstGeom prst="rect">
-            <a:avLst/>
-          </a:prstGeom>
-          <a:noFill/>
-        </p:spPr>
-        <p:txBody>
-          <a:bodyPr wrap="none" lIns="0" rIns="0" tIns="0" bIns="0">
-            <a:spAutoFit/>
-          </a:bodyPr>
-          <a:lstStyle/>
-          <a:p>
-            <a:pPr>
-              <a:lnSpc>
                 <a:spcPts val="2196"/>
               </a:lnSpc>
               <a:spcBef>
@@ -6988,336 +7878,21 @@
               </a:defRPr>
             </a:pPr>
             <a:r>
-              <a:t>固定的 tokenizer 规则</a:t>
-            </a:r>
-          </a:p>
-        </p:txBody>
-      </p:sp>
-      <p:sp>
-        <p:nvSpPr>
-          <p:cNvPr id="21" name="TextBox 20"/>
-          <p:cNvSpPr txBox="1"/>
-          <p:nvPr/>
-        </p:nvSpPr>
-        <p:spPr>
-          <a:xfrm>
-            <a:off x="786384" y="3136391"/>
-            <a:ext cx="2011680" cy="340868"/>
-          </a:xfrm>
-          <a:prstGeom prst="rect">
-            <a:avLst/>
-          </a:prstGeom>
-          <a:noFill/>
-        </p:spPr>
-        <p:txBody>
-          <a:bodyPr wrap="none" lIns="0" rIns="0" tIns="0" bIns="0">
-            <a:spAutoFit/>
-          </a:bodyPr>
-          <a:lstStyle/>
-          <a:p>
-            <a:pPr>
-              <a:lnSpc>
-                <a:spcPts val="2684"/>
-              </a:lnSpc>
-              <a:spcBef>
-                <a:spcPts val="0"/>
-              </a:spcBef>
-              <a:spcAft>
-                <a:spcPts val="0"/>
-              </a:spcAft>
-              <a:defRPr sz="2200" b="1">
-                <a:solidFill>
-                  <a:srgbClr val="2458C6"/>
-                </a:solidFill>
-                <a:latin typeface="Arial Unicode MS"/>
-              </a:defRPr>
-            </a:pPr>
-            <a:r>
-              <a:t>ID → 向量</a:t>
-            </a:r>
-          </a:p>
-        </p:txBody>
-      </p:sp>
-      <p:sp>
-        <p:nvSpPr>
-          <p:cNvPr id="22" name="TextBox 21"/>
-          <p:cNvSpPr txBox="1"/>
-          <p:nvPr/>
-        </p:nvSpPr>
-        <p:spPr>
-          <a:xfrm>
-            <a:off x="2761488" y="3136391"/>
-            <a:ext cx="4160520" cy="338328"/>
-          </a:xfrm>
-          <a:prstGeom prst="rect">
-            <a:avLst/>
-          </a:prstGeom>
-          <a:noFill/>
-        </p:spPr>
-        <p:txBody>
-          <a:bodyPr wrap="none" lIns="0" rIns="0" tIns="0" bIns="0">
-            <a:spAutoFit/>
-          </a:bodyPr>
-          <a:lstStyle/>
-          <a:p>
-            <a:pPr>
-              <a:lnSpc>
-                <a:spcPts val="2440"/>
-              </a:lnSpc>
-              <a:spcBef>
-                <a:spcPts val="0"/>
-              </a:spcBef>
-              <a:spcAft>
-                <a:spcPts val="0"/>
-              </a:spcAft>
-              <a:defRPr sz="2000" b="0">
-                <a:solidFill>
-                  <a:srgbClr val="14263D"/>
-                </a:solidFill>
-                <a:latin typeface="Arial Unicode MS"/>
-              </a:defRPr>
-            </a:pPr>
-            <a:r>
-              <a:t>E[300]、E[304]、E[262]</a:t>
-            </a:r>
-          </a:p>
-        </p:txBody>
-      </p:sp>
-      <p:sp>
-        <p:nvSpPr>
-          <p:cNvPr id="23" name="TextBox 22"/>
-          <p:cNvSpPr txBox="1"/>
-          <p:nvPr/>
-        </p:nvSpPr>
-        <p:spPr>
-          <a:xfrm>
-            <a:off x="2761488" y="3465575"/>
-            <a:ext cx="4160520" cy="292608"/>
-          </a:xfrm>
-          <a:prstGeom prst="rect">
-            <a:avLst/>
-          </a:prstGeom>
-          <a:noFill/>
-        </p:spPr>
-        <p:txBody>
-          <a:bodyPr wrap="none" lIns="0" rIns="0" tIns="0" bIns="0">
-            <a:spAutoFit/>
-          </a:bodyPr>
-          <a:lstStyle/>
-          <a:p>
-            <a:pPr>
-              <a:lnSpc>
-                <a:spcPts val="2196"/>
-              </a:lnSpc>
-              <a:spcBef>
-                <a:spcPts val="0"/>
-              </a:spcBef>
-              <a:spcAft>
-                <a:spcPts val="0"/>
-              </a:spcAft>
-              <a:defRPr sz="1800" b="0">
-                <a:solidFill>
-                  <a:srgbClr val="475569"/>
-                </a:solidFill>
-                <a:latin typeface="Arial Unicode MS"/>
-              </a:defRPr>
-            </a:pPr>
-            <a:r>
-              <a:t>可训练参数；初始可以随机</a:t>
-            </a:r>
-          </a:p>
-        </p:txBody>
-      </p:sp>
-      <p:sp>
-        <p:nvSpPr>
-          <p:cNvPr id="24" name="TextBox 23"/>
-          <p:cNvSpPr txBox="1"/>
-          <p:nvPr/>
-        </p:nvSpPr>
-        <p:spPr>
-          <a:xfrm>
-            <a:off x="786384" y="3849624"/>
-            <a:ext cx="2011680" cy="340868"/>
-          </a:xfrm>
-          <a:prstGeom prst="rect">
-            <a:avLst/>
-          </a:prstGeom>
-          <a:noFill/>
-        </p:spPr>
-        <p:txBody>
-          <a:bodyPr wrap="none" lIns="0" rIns="0" tIns="0" bIns="0">
-            <a:spAutoFit/>
-          </a:bodyPr>
-          <a:lstStyle/>
-          <a:p>
-            <a:pPr>
-              <a:lnSpc>
-                <a:spcPts val="2684"/>
-              </a:lnSpc>
-              <a:spcBef>
-                <a:spcPts val="0"/>
-              </a:spcBef>
-              <a:spcAft>
-                <a:spcPts val="0"/>
-              </a:spcAft>
-              <a:defRPr sz="2200" b="1">
-                <a:solidFill>
-                  <a:srgbClr val="2458C6"/>
-                </a:solidFill>
-                <a:latin typeface="Arial Unicode MS"/>
-              </a:defRPr>
-            </a:pPr>
-            <a:r>
-              <a:t>加入位置</a:t>
-            </a:r>
-          </a:p>
-        </p:txBody>
-      </p:sp>
-      <p:sp>
-        <p:nvSpPr>
-          <p:cNvPr id="25" name="TextBox 24"/>
-          <p:cNvSpPr txBox="1"/>
-          <p:nvPr/>
-        </p:nvSpPr>
-        <p:spPr>
-          <a:xfrm>
-            <a:off x="2761488" y="3849624"/>
-            <a:ext cx="4160520" cy="338328"/>
-          </a:xfrm>
-          <a:prstGeom prst="rect">
-            <a:avLst/>
-          </a:prstGeom>
-          <a:noFill/>
-        </p:spPr>
-        <p:txBody>
-          <a:bodyPr wrap="none" lIns="0" rIns="0" tIns="0" bIns="0">
-            <a:spAutoFit/>
-          </a:bodyPr>
-          <a:lstStyle/>
-          <a:p>
-            <a:pPr>
-              <a:lnSpc>
-                <a:spcPts val="2440"/>
-              </a:lnSpc>
-              <a:spcBef>
-                <a:spcPts val="0"/>
-              </a:spcBef>
-              <a:spcAft>
-                <a:spcPts val="0"/>
-              </a:spcAft>
-              <a:defRPr sz="2000" b="0">
-                <a:solidFill>
-                  <a:srgbClr val="14263D"/>
-                </a:solidFill>
-                <a:latin typeface="Arial Unicode MS"/>
-              </a:defRPr>
-            </a:pPr>
-            <a:r>
-              <a:t>位置 0、1、2 → Q/K 的关系</a:t>
-            </a:r>
-          </a:p>
-        </p:txBody>
-      </p:sp>
-      <p:sp>
-        <p:nvSpPr>
-          <p:cNvPr id="26" name="TextBox 25"/>
-          <p:cNvSpPr txBox="1"/>
-          <p:nvPr/>
-        </p:nvSpPr>
-        <p:spPr>
-          <a:xfrm>
-            <a:off x="2761488" y="4178808"/>
-            <a:ext cx="4160520" cy="292608"/>
-          </a:xfrm>
-          <a:prstGeom prst="rect">
-            <a:avLst/>
-          </a:prstGeom>
-          <a:noFill/>
-        </p:spPr>
-        <p:txBody>
-          <a:bodyPr wrap="none" lIns="0" rIns="0" tIns="0" bIns="0">
-            <a:spAutoFit/>
-          </a:bodyPr>
-          <a:lstStyle/>
-          <a:p>
-            <a:pPr>
-              <a:lnSpc>
-                <a:spcPts val="2196"/>
-              </a:lnSpc>
-              <a:spcBef>
-                <a:spcPts val="0"/>
-              </a:spcBef>
-              <a:spcAft>
-                <a:spcPts val="0"/>
-              </a:spcAft>
-              <a:defRPr sz="1800" b="0">
-                <a:solidFill>
-                  <a:srgbClr val="475569"/>
-                </a:solidFill>
-                <a:latin typeface="Arial Unicode MS"/>
-              </a:defRPr>
-            </a:pPr>
-            <a:r>
-              <a:t>同一 ID 查同一行，位置另处理</a:t>
-            </a:r>
-          </a:p>
-        </p:txBody>
-      </p:sp>
-      <p:sp>
-        <p:nvSpPr>
-          <p:cNvPr id="27" name="TextBox 26"/>
-          <p:cNvSpPr txBox="1"/>
-          <p:nvPr/>
-        </p:nvSpPr>
-        <p:spPr>
-          <a:xfrm>
-            <a:off x="786384" y="4535424"/>
-            <a:ext cx="6217920" cy="283464"/>
-          </a:xfrm>
-          <a:prstGeom prst="rect">
-            <a:avLst/>
-          </a:prstGeom>
-          <a:noFill/>
-        </p:spPr>
-        <p:txBody>
-          <a:bodyPr wrap="none" lIns="0" rIns="0" tIns="0" bIns="0">
-            <a:spAutoFit/>
-          </a:bodyPr>
-          <a:lstStyle/>
-          <a:p>
-            <a:pPr>
-              <a:lnSpc>
-                <a:spcPts val="2196"/>
-              </a:lnSpc>
-              <a:spcBef>
-                <a:spcPts val="0"/>
-              </a:spcBef>
-              <a:spcAft>
-                <a:spcPts val="0"/>
-              </a:spcAft>
-              <a:defRPr sz="1800" b="0">
-                <a:solidFill>
-                  <a:srgbClr val="475569"/>
-                </a:solidFill>
-                <a:latin typeface="Arial Unicode MS"/>
-              </a:defRPr>
-            </a:pPr>
-            <a:r>
-              <a:t>这里先看普通token；batch页再加入起止标记与pad。</a:t>
-            </a:r>
-          </a:p>
-        </p:txBody>
-      </p:sp>
-      <p:sp>
-        <p:nvSpPr>
-          <p:cNvPr id="28" name="Rounded Rectangle 27"/>
+              <a:t>生成的 ID 接回序列，继续下一轮。</a:t>
+            </a:r>
+          </a:p>
+        </p:txBody>
+      </p:sp>
+      <p:sp>
+        <p:nvSpPr>
+          <p:cNvPr id="43" name="Rounded Rectangle 42"/>
           <p:cNvSpPr/>
           <p:nvPr/>
         </p:nvSpPr>
         <p:spPr>
           <a:xfrm>
-            <a:off x="7452360" y="1901952"/>
-            <a:ext cx="4160520" cy="2926080"/>
+            <a:off x="5715000" y="1901952"/>
+            <a:ext cx="5897880" cy="3803904"/>
           </a:xfrm>
           <a:prstGeom prst="roundRect">
             <a:avLst>
@@ -7355,14 +7930,14 @@
       </p:sp>
       <p:sp>
         <p:nvSpPr>
-          <p:cNvPr id="29" name="TextBox 28"/>
-          <p:cNvSpPr txBox="1"/>
-          <p:nvPr/>
-        </p:nvSpPr>
-        <p:spPr>
-          <a:xfrm>
-            <a:off x="7635240" y="2039112"/>
-            <a:ext cx="3794759" cy="283464"/>
+          <p:cNvPr id="44" name="TextBox 43"/>
+          <p:cNvSpPr txBox="1"/>
+          <p:nvPr/>
+        </p:nvSpPr>
+        <p:spPr>
+          <a:xfrm>
+            <a:off x="5897880" y="2039112"/>
+            <a:ext cx="5532120" cy="283464"/>
           </a:xfrm>
           <a:prstGeom prst="rect">
             <a:avLst/>
@@ -7393,21 +7968,1538 @@
               </a:defRPr>
             </a:pPr>
             <a:r>
-              <a:t>最终用途：预测下一个 token</a:t>
-            </a:r>
-          </a:p>
-        </p:txBody>
-      </p:sp>
-      <p:sp>
-        <p:nvSpPr>
-          <p:cNvPr id="30" name="TextBox 29"/>
-          <p:cNvSpPr txBox="1"/>
-          <p:nvPr/>
-        </p:nvSpPr>
-        <p:spPr>
-          <a:xfrm>
-            <a:off x="7680960" y="2450592"/>
-            <a:ext cx="3685032" cy="571500"/>
+              <a:t>单层 Decoder Block 展开（Pre-Norm）</a:t>
+            </a:r>
+          </a:p>
+        </p:txBody>
+      </p:sp>
+      <p:sp>
+        <p:nvSpPr>
+          <p:cNvPr id="45" name="Rounded Rectangle 44"/>
+          <p:cNvSpPr/>
+          <p:nvPr/>
+        </p:nvSpPr>
+        <p:spPr>
+          <a:xfrm>
+            <a:off x="7315200" y="2468880"/>
+            <a:ext cx="3310128" cy="384048"/>
+          </a:xfrm>
+          <a:prstGeom prst="roundRect">
+            <a:avLst>
+              <a:gd name="adj" fmla="val 6000"/>
+            </a:avLst>
+          </a:prstGeom>
+          <a:solidFill>
+            <a:srgbClr val="E8F0FC"/>
+          </a:solidFill>
+          <a:ln>
+            <a:noFill/>
+          </a:ln>
+        </p:spPr>
+        <p:style>
+          <a:lnRef idx="1">
+            <a:schemeClr val="accent1"/>
+          </a:lnRef>
+          <a:fillRef idx="3">
+            <a:schemeClr val="accent1"/>
+          </a:fillRef>
+          <a:effectRef idx="2">
+            <a:schemeClr val="accent1"/>
+          </a:effectRef>
+          <a:fontRef idx="minor">
+            <a:schemeClr val="lt1"/>
+          </a:fontRef>
+        </p:style>
+        <p:txBody>
+          <a:bodyPr rtlCol="0" anchor="ctr"/>
+          <a:lstStyle/>
+          <a:p>
+            <a:pPr algn="ctr"/>
+          </a:p>
+        </p:txBody>
+      </p:sp>
+      <p:sp>
+        <p:nvSpPr>
+          <p:cNvPr id="46" name="TextBox 45"/>
+          <p:cNvSpPr txBox="1"/>
+          <p:nvPr/>
+        </p:nvSpPr>
+        <p:spPr>
+          <a:xfrm>
+            <a:off x="7388352" y="2510028"/>
+            <a:ext cx="3163824" cy="310896"/>
+          </a:xfrm>
+          <a:prstGeom prst="rect">
+            <a:avLst/>
+          </a:prstGeom>
+          <a:noFill/>
+        </p:spPr>
+        <p:txBody>
+          <a:bodyPr wrap="none" lIns="0" rIns="0" tIns="0" bIns="0">
+            <a:spAutoFit/>
+          </a:bodyPr>
+          <a:lstStyle/>
+          <a:p>
+            <a:pPr algn="ctr">
+              <a:lnSpc>
+                <a:spcPts val="2196"/>
+              </a:lnSpc>
+              <a:spcBef>
+                <a:spcPts val="0"/>
+              </a:spcBef>
+              <a:spcAft>
+                <a:spcPts val="0"/>
+              </a:spcAft>
+              <a:defRPr sz="1800" b="0">
+                <a:solidFill>
+                  <a:srgbClr val="14263D"/>
+                </a:solidFill>
+                <a:latin typeface="Arial Unicode MS"/>
+              </a:defRPr>
+            </a:pPr>
+            <a:r>
+              <a:t>归一化 Norm</a:t>
+            </a:r>
+          </a:p>
+        </p:txBody>
+      </p:sp>
+      <p:cxnSp>
+        <p:nvCxnSpPr>
+          <p:cNvPr id="47" name="Connector 46"/>
+          <p:cNvCxnSpPr/>
+          <p:nvPr/>
+        </p:nvCxnSpPr>
+        <p:spPr>
+          <a:xfrm>
+            <a:off x="8970264" y="2857500"/>
+            <a:ext cx="0" cy="59436"/>
+          </a:xfrm>
+          <a:prstGeom prst="line">
+            <a:avLst/>
+          </a:prstGeom>
+          <a:ln w="21590">
+            <a:solidFill>
+              <a:srgbClr val="087F8C"/>
+            </a:solidFill>
+          </a:ln>
+        </p:spPr>
+        <p:style>
+          <a:lnRef idx="2">
+            <a:schemeClr val="accent1"/>
+          </a:lnRef>
+          <a:fillRef idx="0">
+            <a:schemeClr val="accent1"/>
+          </a:fillRef>
+          <a:effectRef idx="1">
+            <a:schemeClr val="accent1"/>
+          </a:effectRef>
+          <a:fontRef idx="minor">
+            <a:schemeClr val="tx1"/>
+          </a:fontRef>
+        </p:style>
+      </p:cxnSp>
+      <p:sp>
+        <p:nvSpPr>
+          <p:cNvPr id="48" name="Isosceles Triangle 47"/>
+          <p:cNvSpPr/>
+          <p:nvPr/>
+        </p:nvSpPr>
+        <p:spPr>
+          <a:xfrm rot="10800000">
+            <a:off x="8938260" y="2875788"/>
+            <a:ext cx="64008" cy="82296"/>
+          </a:xfrm>
+          <a:prstGeom prst="triangle">
+            <a:avLst/>
+          </a:prstGeom>
+          <a:solidFill>
+            <a:srgbClr val="087F8C"/>
+          </a:solidFill>
+          <a:ln>
+            <a:noFill/>
+          </a:ln>
+        </p:spPr>
+        <p:style>
+          <a:lnRef idx="1">
+            <a:schemeClr val="accent1"/>
+          </a:lnRef>
+          <a:fillRef idx="3">
+            <a:schemeClr val="accent1"/>
+          </a:fillRef>
+          <a:effectRef idx="2">
+            <a:schemeClr val="accent1"/>
+          </a:effectRef>
+          <a:fontRef idx="minor">
+            <a:schemeClr val="lt1"/>
+          </a:fontRef>
+        </p:style>
+        <p:txBody>
+          <a:bodyPr rtlCol="0" anchor="ctr"/>
+          <a:lstStyle/>
+          <a:p>
+            <a:pPr algn="ctr"/>
+          </a:p>
+        </p:txBody>
+      </p:sp>
+      <p:sp>
+        <p:nvSpPr>
+          <p:cNvPr id="49" name="Rounded Rectangle 48"/>
+          <p:cNvSpPr/>
+          <p:nvPr/>
+        </p:nvSpPr>
+        <p:spPr>
+          <a:xfrm>
+            <a:off x="7315200" y="2926080"/>
+            <a:ext cx="3310128" cy="384048"/>
+          </a:xfrm>
+          <a:prstGeom prst="roundRect">
+            <a:avLst>
+              <a:gd name="adj" fmla="val 6000"/>
+            </a:avLst>
+          </a:prstGeom>
+          <a:solidFill>
+            <a:srgbClr val="DFF0ED"/>
+          </a:solidFill>
+          <a:ln>
+            <a:noFill/>
+          </a:ln>
+        </p:spPr>
+        <p:style>
+          <a:lnRef idx="1">
+            <a:schemeClr val="accent1"/>
+          </a:lnRef>
+          <a:fillRef idx="3">
+            <a:schemeClr val="accent1"/>
+          </a:fillRef>
+          <a:effectRef idx="2">
+            <a:schemeClr val="accent1"/>
+          </a:effectRef>
+          <a:fontRef idx="minor">
+            <a:schemeClr val="lt1"/>
+          </a:fontRef>
+        </p:style>
+        <p:txBody>
+          <a:bodyPr rtlCol="0" anchor="ctr"/>
+          <a:lstStyle/>
+          <a:p>
+            <a:pPr algn="ctr"/>
+          </a:p>
+        </p:txBody>
+      </p:sp>
+      <p:sp>
+        <p:nvSpPr>
+          <p:cNvPr id="50" name="TextBox 49"/>
+          <p:cNvSpPr txBox="1"/>
+          <p:nvPr/>
+        </p:nvSpPr>
+        <p:spPr>
+          <a:xfrm>
+            <a:off x="7388352" y="2967228"/>
+            <a:ext cx="3163824" cy="310896"/>
+          </a:xfrm>
+          <a:prstGeom prst="rect">
+            <a:avLst/>
+          </a:prstGeom>
+          <a:noFill/>
+        </p:spPr>
+        <p:txBody>
+          <a:bodyPr wrap="none" lIns="0" rIns="0" tIns="0" bIns="0">
+            <a:spAutoFit/>
+          </a:bodyPr>
+          <a:lstStyle/>
+          <a:p>
+            <a:pPr algn="ctr">
+              <a:lnSpc>
+                <a:spcPts val="2196"/>
+              </a:lnSpc>
+              <a:spcBef>
+                <a:spcPts val="0"/>
+              </a:spcBef>
+              <a:spcAft>
+                <a:spcPts val="0"/>
+              </a:spcAft>
+              <a:defRPr sz="1800" b="0">
+                <a:solidFill>
+                  <a:srgbClr val="087568"/>
+                </a:solidFill>
+                <a:latin typeface="Arial Unicode MS"/>
+              </a:defRPr>
+            </a:pPr>
+            <a:r>
+              <a:t>因果 MHA：Q/K 用 RoPE</a:t>
+            </a:r>
+          </a:p>
+        </p:txBody>
+      </p:sp>
+      <p:cxnSp>
+        <p:nvCxnSpPr>
+          <p:cNvPr id="51" name="Connector 50"/>
+          <p:cNvCxnSpPr/>
+          <p:nvPr/>
+        </p:nvCxnSpPr>
+        <p:spPr>
+          <a:xfrm>
+            <a:off x="8970264" y="3314700"/>
+            <a:ext cx="0" cy="59436"/>
+          </a:xfrm>
+          <a:prstGeom prst="line">
+            <a:avLst/>
+          </a:prstGeom>
+          <a:ln w="21590">
+            <a:solidFill>
+              <a:srgbClr val="087F8C"/>
+            </a:solidFill>
+          </a:ln>
+        </p:spPr>
+        <p:style>
+          <a:lnRef idx="2">
+            <a:schemeClr val="accent1"/>
+          </a:lnRef>
+          <a:fillRef idx="0">
+            <a:schemeClr val="accent1"/>
+          </a:fillRef>
+          <a:effectRef idx="1">
+            <a:schemeClr val="accent1"/>
+          </a:effectRef>
+          <a:fontRef idx="minor">
+            <a:schemeClr val="tx1"/>
+          </a:fontRef>
+        </p:style>
+      </p:cxnSp>
+      <p:sp>
+        <p:nvSpPr>
+          <p:cNvPr id="52" name="Isosceles Triangle 51"/>
+          <p:cNvSpPr/>
+          <p:nvPr/>
+        </p:nvSpPr>
+        <p:spPr>
+          <a:xfrm rot="10800000">
+            <a:off x="8938260" y="3332988"/>
+            <a:ext cx="64008" cy="82296"/>
+          </a:xfrm>
+          <a:prstGeom prst="triangle">
+            <a:avLst/>
+          </a:prstGeom>
+          <a:solidFill>
+            <a:srgbClr val="087F8C"/>
+          </a:solidFill>
+          <a:ln>
+            <a:noFill/>
+          </a:ln>
+        </p:spPr>
+        <p:style>
+          <a:lnRef idx="1">
+            <a:schemeClr val="accent1"/>
+          </a:lnRef>
+          <a:fillRef idx="3">
+            <a:schemeClr val="accent1"/>
+          </a:fillRef>
+          <a:effectRef idx="2">
+            <a:schemeClr val="accent1"/>
+          </a:effectRef>
+          <a:fontRef idx="minor">
+            <a:schemeClr val="lt1"/>
+          </a:fontRef>
+        </p:style>
+        <p:txBody>
+          <a:bodyPr rtlCol="0" anchor="ctr"/>
+          <a:lstStyle/>
+          <a:p>
+            <a:pPr algn="ctr"/>
+          </a:p>
+        </p:txBody>
+      </p:sp>
+      <p:sp>
+        <p:nvSpPr>
+          <p:cNvPr id="53" name="Rounded Rectangle 52"/>
+          <p:cNvSpPr/>
+          <p:nvPr/>
+        </p:nvSpPr>
+        <p:spPr>
+          <a:xfrm>
+            <a:off x="7315200" y="3383280"/>
+            <a:ext cx="3310128" cy="384048"/>
+          </a:xfrm>
+          <a:prstGeom prst="roundRect">
+            <a:avLst>
+              <a:gd name="adj" fmla="val 6000"/>
+            </a:avLst>
+          </a:prstGeom>
+          <a:solidFill>
+            <a:srgbClr val="E8F0FC"/>
+          </a:solidFill>
+          <a:ln>
+            <a:noFill/>
+          </a:ln>
+        </p:spPr>
+        <p:style>
+          <a:lnRef idx="1">
+            <a:schemeClr val="accent1"/>
+          </a:lnRef>
+          <a:fillRef idx="3">
+            <a:schemeClr val="accent1"/>
+          </a:fillRef>
+          <a:effectRef idx="2">
+            <a:schemeClr val="accent1"/>
+          </a:effectRef>
+          <a:fontRef idx="minor">
+            <a:schemeClr val="lt1"/>
+          </a:fontRef>
+        </p:style>
+        <p:txBody>
+          <a:bodyPr rtlCol="0" anchor="ctr"/>
+          <a:lstStyle/>
+          <a:p>
+            <a:pPr algn="ctr"/>
+          </a:p>
+        </p:txBody>
+      </p:sp>
+      <p:sp>
+        <p:nvSpPr>
+          <p:cNvPr id="54" name="TextBox 53"/>
+          <p:cNvSpPr txBox="1"/>
+          <p:nvPr/>
+        </p:nvSpPr>
+        <p:spPr>
+          <a:xfrm>
+            <a:off x="7388352" y="3424428"/>
+            <a:ext cx="3163824" cy="310896"/>
+          </a:xfrm>
+          <a:prstGeom prst="rect">
+            <a:avLst/>
+          </a:prstGeom>
+          <a:noFill/>
+        </p:spPr>
+        <p:txBody>
+          <a:bodyPr wrap="none" lIns="0" rIns="0" tIns="0" bIns="0">
+            <a:spAutoFit/>
+          </a:bodyPr>
+          <a:lstStyle/>
+          <a:p>
+            <a:pPr algn="ctr">
+              <a:lnSpc>
+                <a:spcPts val="2196"/>
+              </a:lnSpc>
+              <a:spcBef>
+                <a:spcPts val="0"/>
+              </a:spcBef>
+              <a:spcAft>
+                <a:spcPts val="0"/>
+              </a:spcAft>
+              <a:defRPr sz="1800" b="0">
+                <a:solidFill>
+                  <a:srgbClr val="14263D"/>
+                </a:solidFill>
+                <a:latin typeface="Arial Unicode MS"/>
+              </a:defRPr>
+            </a:pPr>
+            <a:r>
+              <a:t>+ 输入 x（残差）</a:t>
+            </a:r>
+          </a:p>
+        </p:txBody>
+      </p:sp>
+      <p:cxnSp>
+        <p:nvCxnSpPr>
+          <p:cNvPr id="55" name="Connector 54"/>
+          <p:cNvCxnSpPr/>
+          <p:nvPr/>
+        </p:nvCxnSpPr>
+        <p:spPr>
+          <a:xfrm>
+            <a:off x="8970264" y="3771900"/>
+            <a:ext cx="0" cy="59436"/>
+          </a:xfrm>
+          <a:prstGeom prst="line">
+            <a:avLst/>
+          </a:prstGeom>
+          <a:ln w="21590">
+            <a:solidFill>
+              <a:srgbClr val="087F8C"/>
+            </a:solidFill>
+          </a:ln>
+        </p:spPr>
+        <p:style>
+          <a:lnRef idx="2">
+            <a:schemeClr val="accent1"/>
+          </a:lnRef>
+          <a:fillRef idx="0">
+            <a:schemeClr val="accent1"/>
+          </a:fillRef>
+          <a:effectRef idx="1">
+            <a:schemeClr val="accent1"/>
+          </a:effectRef>
+          <a:fontRef idx="minor">
+            <a:schemeClr val="tx1"/>
+          </a:fontRef>
+        </p:style>
+      </p:cxnSp>
+      <p:sp>
+        <p:nvSpPr>
+          <p:cNvPr id="56" name="Isosceles Triangle 55"/>
+          <p:cNvSpPr/>
+          <p:nvPr/>
+        </p:nvSpPr>
+        <p:spPr>
+          <a:xfrm rot="10800000">
+            <a:off x="8938260" y="3790188"/>
+            <a:ext cx="64008" cy="82296"/>
+          </a:xfrm>
+          <a:prstGeom prst="triangle">
+            <a:avLst/>
+          </a:prstGeom>
+          <a:solidFill>
+            <a:srgbClr val="087F8C"/>
+          </a:solidFill>
+          <a:ln>
+            <a:noFill/>
+          </a:ln>
+        </p:spPr>
+        <p:style>
+          <a:lnRef idx="1">
+            <a:schemeClr val="accent1"/>
+          </a:lnRef>
+          <a:fillRef idx="3">
+            <a:schemeClr val="accent1"/>
+          </a:fillRef>
+          <a:effectRef idx="2">
+            <a:schemeClr val="accent1"/>
+          </a:effectRef>
+          <a:fontRef idx="minor">
+            <a:schemeClr val="lt1"/>
+          </a:fontRef>
+        </p:style>
+        <p:txBody>
+          <a:bodyPr rtlCol="0" anchor="ctr"/>
+          <a:lstStyle/>
+          <a:p>
+            <a:pPr algn="ctr"/>
+          </a:p>
+        </p:txBody>
+      </p:sp>
+      <p:sp>
+        <p:nvSpPr>
+          <p:cNvPr id="57" name="Rounded Rectangle 56"/>
+          <p:cNvSpPr/>
+          <p:nvPr/>
+        </p:nvSpPr>
+        <p:spPr>
+          <a:xfrm>
+            <a:off x="7315200" y="3840480"/>
+            <a:ext cx="3310128" cy="384048"/>
+          </a:xfrm>
+          <a:prstGeom prst="roundRect">
+            <a:avLst>
+              <a:gd name="adj" fmla="val 6000"/>
+            </a:avLst>
+          </a:prstGeom>
+          <a:solidFill>
+            <a:srgbClr val="E8F0FC"/>
+          </a:solidFill>
+          <a:ln>
+            <a:noFill/>
+          </a:ln>
+        </p:spPr>
+        <p:style>
+          <a:lnRef idx="1">
+            <a:schemeClr val="accent1"/>
+          </a:lnRef>
+          <a:fillRef idx="3">
+            <a:schemeClr val="accent1"/>
+          </a:fillRef>
+          <a:effectRef idx="2">
+            <a:schemeClr val="accent1"/>
+          </a:effectRef>
+          <a:fontRef idx="minor">
+            <a:schemeClr val="lt1"/>
+          </a:fontRef>
+        </p:style>
+        <p:txBody>
+          <a:bodyPr rtlCol="0" anchor="ctr"/>
+          <a:lstStyle/>
+          <a:p>
+            <a:pPr algn="ctr"/>
+          </a:p>
+        </p:txBody>
+      </p:sp>
+      <p:sp>
+        <p:nvSpPr>
+          <p:cNvPr id="58" name="TextBox 57"/>
+          <p:cNvSpPr txBox="1"/>
+          <p:nvPr/>
+        </p:nvSpPr>
+        <p:spPr>
+          <a:xfrm>
+            <a:off x="7388352" y="3881628"/>
+            <a:ext cx="3163824" cy="310896"/>
+          </a:xfrm>
+          <a:prstGeom prst="rect">
+            <a:avLst/>
+          </a:prstGeom>
+          <a:noFill/>
+        </p:spPr>
+        <p:txBody>
+          <a:bodyPr wrap="none" lIns="0" rIns="0" tIns="0" bIns="0">
+            <a:spAutoFit/>
+          </a:bodyPr>
+          <a:lstStyle/>
+          <a:p>
+            <a:pPr algn="ctr">
+              <a:lnSpc>
+                <a:spcPts val="2196"/>
+              </a:lnSpc>
+              <a:spcBef>
+                <a:spcPts val="0"/>
+              </a:spcBef>
+              <a:spcAft>
+                <a:spcPts val="0"/>
+              </a:spcAft>
+              <a:defRPr sz="1800" b="0">
+                <a:solidFill>
+                  <a:srgbClr val="14263D"/>
+                </a:solidFill>
+                <a:latin typeface="Arial Unicode MS"/>
+              </a:defRPr>
+            </a:pPr>
+            <a:r>
+              <a:t>归一化 Norm</a:t>
+            </a:r>
+          </a:p>
+        </p:txBody>
+      </p:sp>
+      <p:cxnSp>
+        <p:nvCxnSpPr>
+          <p:cNvPr id="59" name="Connector 58"/>
+          <p:cNvCxnSpPr/>
+          <p:nvPr/>
+        </p:nvCxnSpPr>
+        <p:spPr>
+          <a:xfrm>
+            <a:off x="8970264" y="4229100"/>
+            <a:ext cx="0" cy="59436"/>
+          </a:xfrm>
+          <a:prstGeom prst="line">
+            <a:avLst/>
+          </a:prstGeom>
+          <a:ln w="21590">
+            <a:solidFill>
+              <a:srgbClr val="087F8C"/>
+            </a:solidFill>
+          </a:ln>
+        </p:spPr>
+        <p:style>
+          <a:lnRef idx="2">
+            <a:schemeClr val="accent1"/>
+          </a:lnRef>
+          <a:fillRef idx="0">
+            <a:schemeClr val="accent1"/>
+          </a:fillRef>
+          <a:effectRef idx="1">
+            <a:schemeClr val="accent1"/>
+          </a:effectRef>
+          <a:fontRef idx="minor">
+            <a:schemeClr val="tx1"/>
+          </a:fontRef>
+        </p:style>
+      </p:cxnSp>
+      <p:sp>
+        <p:nvSpPr>
+          <p:cNvPr id="60" name="Isosceles Triangle 59"/>
+          <p:cNvSpPr/>
+          <p:nvPr/>
+        </p:nvSpPr>
+        <p:spPr>
+          <a:xfrm rot="10800000">
+            <a:off x="8938260" y="4247388"/>
+            <a:ext cx="64008" cy="82296"/>
+          </a:xfrm>
+          <a:prstGeom prst="triangle">
+            <a:avLst/>
+          </a:prstGeom>
+          <a:solidFill>
+            <a:srgbClr val="087F8C"/>
+          </a:solidFill>
+          <a:ln>
+            <a:noFill/>
+          </a:ln>
+        </p:spPr>
+        <p:style>
+          <a:lnRef idx="1">
+            <a:schemeClr val="accent1"/>
+          </a:lnRef>
+          <a:fillRef idx="3">
+            <a:schemeClr val="accent1"/>
+          </a:fillRef>
+          <a:effectRef idx="2">
+            <a:schemeClr val="accent1"/>
+          </a:effectRef>
+          <a:fontRef idx="minor">
+            <a:schemeClr val="lt1"/>
+          </a:fontRef>
+        </p:style>
+        <p:txBody>
+          <a:bodyPr rtlCol="0" anchor="ctr"/>
+          <a:lstStyle/>
+          <a:p>
+            <a:pPr algn="ctr"/>
+          </a:p>
+        </p:txBody>
+      </p:sp>
+      <p:sp>
+        <p:nvSpPr>
+          <p:cNvPr id="61" name="Rounded Rectangle 60"/>
+          <p:cNvSpPr/>
+          <p:nvPr/>
+        </p:nvSpPr>
+        <p:spPr>
+          <a:xfrm>
+            <a:off x="7315200" y="4297680"/>
+            <a:ext cx="3310128" cy="384048"/>
+          </a:xfrm>
+          <a:prstGeom prst="roundRect">
+            <a:avLst>
+              <a:gd name="adj" fmla="val 6000"/>
+            </a:avLst>
+          </a:prstGeom>
+          <a:solidFill>
+            <a:srgbClr val="E8F0FC"/>
+          </a:solidFill>
+          <a:ln>
+            <a:noFill/>
+          </a:ln>
+        </p:spPr>
+        <p:style>
+          <a:lnRef idx="1">
+            <a:schemeClr val="accent1"/>
+          </a:lnRef>
+          <a:fillRef idx="3">
+            <a:schemeClr val="accent1"/>
+          </a:fillRef>
+          <a:effectRef idx="2">
+            <a:schemeClr val="accent1"/>
+          </a:effectRef>
+          <a:fontRef idx="minor">
+            <a:schemeClr val="lt1"/>
+          </a:fontRef>
+        </p:style>
+        <p:txBody>
+          <a:bodyPr rtlCol="0" anchor="ctr"/>
+          <a:lstStyle/>
+          <a:p>
+            <a:pPr algn="ctr"/>
+          </a:p>
+        </p:txBody>
+      </p:sp>
+      <p:sp>
+        <p:nvSpPr>
+          <p:cNvPr id="62" name="TextBox 61"/>
+          <p:cNvSpPr txBox="1"/>
+          <p:nvPr/>
+        </p:nvSpPr>
+        <p:spPr>
+          <a:xfrm>
+            <a:off x="7388352" y="4338828"/>
+            <a:ext cx="3163824" cy="310896"/>
+          </a:xfrm>
+          <a:prstGeom prst="rect">
+            <a:avLst/>
+          </a:prstGeom>
+          <a:noFill/>
+        </p:spPr>
+        <p:txBody>
+          <a:bodyPr wrap="none" lIns="0" rIns="0" tIns="0" bIns="0">
+            <a:spAutoFit/>
+          </a:bodyPr>
+          <a:lstStyle/>
+          <a:p>
+            <a:pPr algn="ctr">
+              <a:lnSpc>
+                <a:spcPts val="2196"/>
+              </a:lnSpc>
+              <a:spcBef>
+                <a:spcPts val="0"/>
+              </a:spcBef>
+              <a:spcAft>
+                <a:spcPts val="0"/>
+              </a:spcAft>
+              <a:defRPr sz="1800" b="0">
+                <a:solidFill>
+                  <a:srgbClr val="14263D"/>
+                </a:solidFill>
+                <a:latin typeface="Arial Unicode MS"/>
+              </a:defRPr>
+            </a:pPr>
+            <a:r>
+              <a:t>FFN / MLP：逐位置加工</a:t>
+            </a:r>
+          </a:p>
+        </p:txBody>
+      </p:sp>
+      <p:cxnSp>
+        <p:nvCxnSpPr>
+          <p:cNvPr id="63" name="Connector 62"/>
+          <p:cNvCxnSpPr/>
+          <p:nvPr/>
+        </p:nvCxnSpPr>
+        <p:spPr>
+          <a:xfrm>
+            <a:off x="8970264" y="4686300"/>
+            <a:ext cx="0" cy="59436"/>
+          </a:xfrm>
+          <a:prstGeom prst="line">
+            <a:avLst/>
+          </a:prstGeom>
+          <a:ln w="21590">
+            <a:solidFill>
+              <a:srgbClr val="087F8C"/>
+            </a:solidFill>
+          </a:ln>
+        </p:spPr>
+        <p:style>
+          <a:lnRef idx="2">
+            <a:schemeClr val="accent1"/>
+          </a:lnRef>
+          <a:fillRef idx="0">
+            <a:schemeClr val="accent1"/>
+          </a:fillRef>
+          <a:effectRef idx="1">
+            <a:schemeClr val="accent1"/>
+          </a:effectRef>
+          <a:fontRef idx="minor">
+            <a:schemeClr val="tx1"/>
+          </a:fontRef>
+        </p:style>
+      </p:cxnSp>
+      <p:sp>
+        <p:nvSpPr>
+          <p:cNvPr id="64" name="Isosceles Triangle 63"/>
+          <p:cNvSpPr/>
+          <p:nvPr/>
+        </p:nvSpPr>
+        <p:spPr>
+          <a:xfrm rot="10800000">
+            <a:off x="8938260" y="4704588"/>
+            <a:ext cx="64008" cy="82296"/>
+          </a:xfrm>
+          <a:prstGeom prst="triangle">
+            <a:avLst/>
+          </a:prstGeom>
+          <a:solidFill>
+            <a:srgbClr val="087F8C"/>
+          </a:solidFill>
+          <a:ln>
+            <a:noFill/>
+          </a:ln>
+        </p:spPr>
+        <p:style>
+          <a:lnRef idx="1">
+            <a:schemeClr val="accent1"/>
+          </a:lnRef>
+          <a:fillRef idx="3">
+            <a:schemeClr val="accent1"/>
+          </a:fillRef>
+          <a:effectRef idx="2">
+            <a:schemeClr val="accent1"/>
+          </a:effectRef>
+          <a:fontRef idx="minor">
+            <a:schemeClr val="lt1"/>
+          </a:fontRef>
+        </p:style>
+        <p:txBody>
+          <a:bodyPr rtlCol="0" anchor="ctr"/>
+          <a:lstStyle/>
+          <a:p>
+            <a:pPr algn="ctr"/>
+          </a:p>
+        </p:txBody>
+      </p:sp>
+      <p:sp>
+        <p:nvSpPr>
+          <p:cNvPr id="65" name="Rounded Rectangle 64"/>
+          <p:cNvSpPr/>
+          <p:nvPr/>
+        </p:nvSpPr>
+        <p:spPr>
+          <a:xfrm>
+            <a:off x="7315200" y="4754880"/>
+            <a:ext cx="3310128" cy="384048"/>
+          </a:xfrm>
+          <a:prstGeom prst="roundRect">
+            <a:avLst>
+              <a:gd name="adj" fmla="val 6000"/>
+            </a:avLst>
+          </a:prstGeom>
+          <a:solidFill>
+            <a:srgbClr val="E8F0FC"/>
+          </a:solidFill>
+          <a:ln>
+            <a:noFill/>
+          </a:ln>
+        </p:spPr>
+        <p:style>
+          <a:lnRef idx="1">
+            <a:schemeClr val="accent1"/>
+          </a:lnRef>
+          <a:fillRef idx="3">
+            <a:schemeClr val="accent1"/>
+          </a:fillRef>
+          <a:effectRef idx="2">
+            <a:schemeClr val="accent1"/>
+          </a:effectRef>
+          <a:fontRef idx="minor">
+            <a:schemeClr val="lt1"/>
+          </a:fontRef>
+        </p:style>
+        <p:txBody>
+          <a:bodyPr rtlCol="0" anchor="ctr"/>
+          <a:lstStyle/>
+          <a:p>
+            <a:pPr algn="ctr"/>
+          </a:p>
+        </p:txBody>
+      </p:sp>
+      <p:sp>
+        <p:nvSpPr>
+          <p:cNvPr id="66" name="TextBox 65"/>
+          <p:cNvSpPr txBox="1"/>
+          <p:nvPr/>
+        </p:nvSpPr>
+        <p:spPr>
+          <a:xfrm>
+            <a:off x="7388352" y="4796028"/>
+            <a:ext cx="3163824" cy="310896"/>
+          </a:xfrm>
+          <a:prstGeom prst="rect">
+            <a:avLst/>
+          </a:prstGeom>
+          <a:noFill/>
+        </p:spPr>
+        <p:txBody>
+          <a:bodyPr wrap="none" lIns="0" rIns="0" tIns="0" bIns="0">
+            <a:spAutoFit/>
+          </a:bodyPr>
+          <a:lstStyle/>
+          <a:p>
+            <a:pPr algn="ctr">
+              <a:lnSpc>
+                <a:spcPts val="2196"/>
+              </a:lnSpc>
+              <a:spcBef>
+                <a:spcPts val="0"/>
+              </a:spcBef>
+              <a:spcAft>
+                <a:spcPts val="0"/>
+              </a:spcAft>
+              <a:defRPr sz="1800" b="0">
+                <a:solidFill>
+                  <a:srgbClr val="14263D"/>
+                </a:solidFill>
+                <a:latin typeface="Arial Unicode MS"/>
+              </a:defRPr>
+            </a:pPr>
+            <a:r>
+              <a:t>+ 中间 h（残差）</a:t>
+            </a:r>
+          </a:p>
+        </p:txBody>
+      </p:sp>
+      <p:cxnSp>
+        <p:nvCxnSpPr>
+          <p:cNvPr id="67" name="Connector 66"/>
+          <p:cNvCxnSpPr/>
+          <p:nvPr/>
+        </p:nvCxnSpPr>
+        <p:spPr>
+          <a:xfrm>
+            <a:off x="8970264" y="2295144"/>
+            <a:ext cx="0" cy="155448"/>
+          </a:xfrm>
+          <a:prstGeom prst="line">
+            <a:avLst/>
+          </a:prstGeom>
+          <a:ln w="21590">
+            <a:solidFill>
+              <a:srgbClr val="087F8C"/>
+            </a:solidFill>
+          </a:ln>
+        </p:spPr>
+        <p:style>
+          <a:lnRef idx="2">
+            <a:schemeClr val="accent1"/>
+          </a:lnRef>
+          <a:fillRef idx="0">
+            <a:schemeClr val="accent1"/>
+          </a:fillRef>
+          <a:effectRef idx="1">
+            <a:schemeClr val="accent1"/>
+          </a:effectRef>
+          <a:fontRef idx="minor">
+            <a:schemeClr val="tx1"/>
+          </a:fontRef>
+        </p:style>
+      </p:cxnSp>
+      <p:sp>
+        <p:nvSpPr>
+          <p:cNvPr id="68" name="Isosceles Triangle 67"/>
+          <p:cNvSpPr/>
+          <p:nvPr/>
+        </p:nvSpPr>
+        <p:spPr>
+          <a:xfrm rot="10800000">
+            <a:off x="8938260" y="2409444"/>
+            <a:ext cx="64008" cy="82296"/>
+          </a:xfrm>
+          <a:prstGeom prst="triangle">
+            <a:avLst/>
+          </a:prstGeom>
+          <a:solidFill>
+            <a:srgbClr val="087F8C"/>
+          </a:solidFill>
+          <a:ln>
+            <a:noFill/>
+          </a:ln>
+        </p:spPr>
+        <p:style>
+          <a:lnRef idx="1">
+            <a:schemeClr val="accent1"/>
+          </a:lnRef>
+          <a:fillRef idx="3">
+            <a:schemeClr val="accent1"/>
+          </a:fillRef>
+          <a:effectRef idx="2">
+            <a:schemeClr val="accent1"/>
+          </a:effectRef>
+          <a:fontRef idx="minor">
+            <a:schemeClr val="lt1"/>
+          </a:fontRef>
+        </p:style>
+        <p:txBody>
+          <a:bodyPr rtlCol="0" anchor="ctr"/>
+          <a:lstStyle/>
+          <a:p>
+            <a:pPr algn="ctr"/>
+          </a:p>
+        </p:txBody>
+      </p:sp>
+      <p:cxnSp>
+        <p:nvCxnSpPr>
+          <p:cNvPr id="69" name="Connector 68"/>
+          <p:cNvCxnSpPr/>
+          <p:nvPr/>
+        </p:nvCxnSpPr>
+        <p:spPr>
+          <a:xfrm flipH="1">
+            <a:off x="6601968" y="2340864"/>
+            <a:ext cx="2368296" cy="0"/>
+          </a:xfrm>
+          <a:prstGeom prst="line">
+            <a:avLst/>
+          </a:prstGeom>
+          <a:ln w="21590">
+            <a:solidFill>
+              <a:srgbClr val="087F8C"/>
+            </a:solidFill>
+          </a:ln>
+        </p:spPr>
+        <p:style>
+          <a:lnRef idx="2">
+            <a:schemeClr val="accent1"/>
+          </a:lnRef>
+          <a:fillRef idx="0">
+            <a:schemeClr val="accent1"/>
+          </a:fillRef>
+          <a:effectRef idx="1">
+            <a:schemeClr val="accent1"/>
+          </a:effectRef>
+          <a:fontRef idx="minor">
+            <a:schemeClr val="tx1"/>
+          </a:fontRef>
+        </p:style>
+      </p:cxnSp>
+      <p:cxnSp>
+        <p:nvCxnSpPr>
+          <p:cNvPr id="70" name="Connector 69"/>
+          <p:cNvCxnSpPr/>
+          <p:nvPr/>
+        </p:nvCxnSpPr>
+        <p:spPr>
+          <a:xfrm>
+            <a:off x="6601968" y="2340864"/>
+            <a:ext cx="0" cy="1234440"/>
+          </a:xfrm>
+          <a:prstGeom prst="line">
+            <a:avLst/>
+          </a:prstGeom>
+          <a:ln w="21590">
+            <a:solidFill>
+              <a:srgbClr val="087F8C"/>
+            </a:solidFill>
+          </a:ln>
+        </p:spPr>
+        <p:style>
+          <a:lnRef idx="2">
+            <a:schemeClr val="accent1"/>
+          </a:lnRef>
+          <a:fillRef idx="0">
+            <a:schemeClr val="accent1"/>
+          </a:fillRef>
+          <a:effectRef idx="1">
+            <a:schemeClr val="accent1"/>
+          </a:effectRef>
+          <a:fontRef idx="minor">
+            <a:schemeClr val="tx1"/>
+          </a:fontRef>
+        </p:style>
+      </p:cxnSp>
+      <p:cxnSp>
+        <p:nvCxnSpPr>
+          <p:cNvPr id="71" name="Connector 70"/>
+          <p:cNvCxnSpPr/>
+          <p:nvPr/>
+        </p:nvCxnSpPr>
+        <p:spPr>
+          <a:xfrm>
+            <a:off x="6601968" y="3575304"/>
+            <a:ext cx="694944" cy="0"/>
+          </a:xfrm>
+          <a:prstGeom prst="line">
+            <a:avLst/>
+          </a:prstGeom>
+          <a:ln w="21590">
+            <a:solidFill>
+              <a:srgbClr val="087F8C"/>
+            </a:solidFill>
+          </a:ln>
+        </p:spPr>
+        <p:style>
+          <a:lnRef idx="2">
+            <a:schemeClr val="accent1"/>
+          </a:lnRef>
+          <a:fillRef idx="0">
+            <a:schemeClr val="accent1"/>
+          </a:fillRef>
+          <a:effectRef idx="1">
+            <a:schemeClr val="accent1"/>
+          </a:effectRef>
+          <a:fontRef idx="minor">
+            <a:schemeClr val="tx1"/>
+          </a:fontRef>
+        </p:style>
+      </p:cxnSp>
+      <p:sp>
+        <p:nvSpPr>
+          <p:cNvPr id="72" name="Isosceles Triangle 71"/>
+          <p:cNvSpPr/>
+          <p:nvPr/>
+        </p:nvSpPr>
+        <p:spPr>
+          <a:xfrm rot="5400000">
+            <a:off x="7264908" y="3534156"/>
+            <a:ext cx="64008" cy="82296"/>
+          </a:xfrm>
+          <a:prstGeom prst="triangle">
+            <a:avLst/>
+          </a:prstGeom>
+          <a:solidFill>
+            <a:srgbClr val="087F8C"/>
+          </a:solidFill>
+          <a:ln>
+            <a:noFill/>
+          </a:ln>
+        </p:spPr>
+        <p:style>
+          <a:lnRef idx="1">
+            <a:schemeClr val="accent1"/>
+          </a:lnRef>
+          <a:fillRef idx="3">
+            <a:schemeClr val="accent1"/>
+          </a:fillRef>
+          <a:effectRef idx="2">
+            <a:schemeClr val="accent1"/>
+          </a:effectRef>
+          <a:fontRef idx="minor">
+            <a:schemeClr val="lt1"/>
+          </a:fontRef>
+        </p:style>
+        <p:txBody>
+          <a:bodyPr rtlCol="0" anchor="ctr"/>
+          <a:lstStyle/>
+          <a:p>
+            <a:pPr algn="ctr"/>
+          </a:p>
+        </p:txBody>
+      </p:sp>
+      <p:sp>
+        <p:nvSpPr>
+          <p:cNvPr id="73" name="TextBox 72"/>
+          <p:cNvSpPr txBox="1"/>
+          <p:nvPr/>
+        </p:nvSpPr>
+        <p:spPr>
+          <a:xfrm>
+            <a:off x="5925312" y="2944368"/>
+            <a:ext cx="566928" cy="310896"/>
+          </a:xfrm>
+          <a:prstGeom prst="rect">
+            <a:avLst/>
+          </a:prstGeom>
+          <a:noFill/>
+        </p:spPr>
+        <p:txBody>
+          <a:bodyPr wrap="none" lIns="0" rIns="0" tIns="0" bIns="0">
+            <a:spAutoFit/>
+          </a:bodyPr>
+          <a:lstStyle/>
+          <a:p>
+            <a:pPr algn="ctr">
+              <a:lnSpc>
+                <a:spcPts val="2440"/>
+              </a:lnSpc>
+              <a:spcBef>
+                <a:spcPts val="0"/>
+              </a:spcBef>
+              <a:spcAft>
+                <a:spcPts val="0"/>
+              </a:spcAft>
+              <a:defRPr sz="2000" b="0">
+                <a:solidFill>
+                  <a:srgbClr val="087F8C"/>
+                </a:solidFill>
+                <a:latin typeface="Arial Unicode MS"/>
+              </a:defRPr>
+            </a:pPr>
+            <a:r>
+              <a:t>x</a:t>
+            </a:r>
+          </a:p>
+        </p:txBody>
+      </p:sp>
+      <p:cxnSp>
+        <p:nvCxnSpPr>
+          <p:cNvPr id="74" name="Connector 73"/>
+          <p:cNvCxnSpPr/>
+          <p:nvPr/>
+        </p:nvCxnSpPr>
+        <p:spPr>
+          <a:xfrm>
+            <a:off x="8970264" y="3803904"/>
+            <a:ext cx="2139696" cy="0"/>
+          </a:xfrm>
+          <a:prstGeom prst="line">
+            <a:avLst/>
+          </a:prstGeom>
+          <a:ln w="21590">
+            <a:solidFill>
+              <a:srgbClr val="087F8C"/>
+            </a:solidFill>
+          </a:ln>
+        </p:spPr>
+        <p:style>
+          <a:lnRef idx="2">
+            <a:schemeClr val="accent1"/>
+          </a:lnRef>
+          <a:fillRef idx="0">
+            <a:schemeClr val="accent1"/>
+          </a:fillRef>
+          <a:effectRef idx="1">
+            <a:schemeClr val="accent1"/>
+          </a:effectRef>
+          <a:fontRef idx="minor">
+            <a:schemeClr val="tx1"/>
+          </a:fontRef>
+        </p:style>
+      </p:cxnSp>
+      <p:cxnSp>
+        <p:nvCxnSpPr>
+          <p:cNvPr id="75" name="Connector 74"/>
+          <p:cNvCxnSpPr/>
+          <p:nvPr/>
+        </p:nvCxnSpPr>
+        <p:spPr>
+          <a:xfrm>
+            <a:off x="11109960" y="3803904"/>
+            <a:ext cx="0" cy="1143000"/>
+          </a:xfrm>
+          <a:prstGeom prst="line">
+            <a:avLst/>
+          </a:prstGeom>
+          <a:ln w="21590">
+            <a:solidFill>
+              <a:srgbClr val="087F8C"/>
+            </a:solidFill>
+          </a:ln>
+        </p:spPr>
+        <p:style>
+          <a:lnRef idx="2">
+            <a:schemeClr val="accent1"/>
+          </a:lnRef>
+          <a:fillRef idx="0">
+            <a:schemeClr val="accent1"/>
+          </a:fillRef>
+          <a:effectRef idx="1">
+            <a:schemeClr val="accent1"/>
+          </a:effectRef>
+          <a:fontRef idx="minor">
+            <a:schemeClr val="tx1"/>
+          </a:fontRef>
+        </p:style>
+      </p:cxnSp>
+      <p:cxnSp>
+        <p:nvCxnSpPr>
+          <p:cNvPr id="76" name="Connector 75"/>
+          <p:cNvCxnSpPr/>
+          <p:nvPr/>
+        </p:nvCxnSpPr>
+        <p:spPr>
+          <a:xfrm flipH="1">
+            <a:off x="10643616" y="4946904"/>
+            <a:ext cx="466344" cy="0"/>
+          </a:xfrm>
+          <a:prstGeom prst="line">
+            <a:avLst/>
+          </a:prstGeom>
+          <a:ln w="21590">
+            <a:solidFill>
+              <a:srgbClr val="087F8C"/>
+            </a:solidFill>
+          </a:ln>
+        </p:spPr>
+        <p:style>
+          <a:lnRef idx="2">
+            <a:schemeClr val="accent1"/>
+          </a:lnRef>
+          <a:fillRef idx="0">
+            <a:schemeClr val="accent1"/>
+          </a:fillRef>
+          <a:effectRef idx="1">
+            <a:schemeClr val="accent1"/>
+          </a:effectRef>
+          <a:fontRef idx="minor">
+            <a:schemeClr val="tx1"/>
+          </a:fontRef>
+        </p:style>
+      </p:cxnSp>
+      <p:sp>
+        <p:nvSpPr>
+          <p:cNvPr id="77" name="Isosceles Triangle 76"/>
+          <p:cNvSpPr/>
+          <p:nvPr/>
+        </p:nvSpPr>
+        <p:spPr>
+          <a:xfrm rot="16200000">
+            <a:off x="10611612" y="4905756"/>
+            <a:ext cx="64008" cy="82296"/>
+          </a:xfrm>
+          <a:prstGeom prst="triangle">
+            <a:avLst/>
+          </a:prstGeom>
+          <a:solidFill>
+            <a:srgbClr val="087F8C"/>
+          </a:solidFill>
+          <a:ln>
+            <a:noFill/>
+          </a:ln>
+        </p:spPr>
+        <p:style>
+          <a:lnRef idx="1">
+            <a:schemeClr val="accent1"/>
+          </a:lnRef>
+          <a:fillRef idx="3">
+            <a:schemeClr val="accent1"/>
+          </a:fillRef>
+          <a:effectRef idx="2">
+            <a:schemeClr val="accent1"/>
+          </a:effectRef>
+          <a:fontRef idx="minor">
+            <a:schemeClr val="lt1"/>
+          </a:fontRef>
+        </p:style>
+        <p:txBody>
+          <a:bodyPr rtlCol="0" anchor="ctr"/>
+          <a:lstStyle/>
+          <a:p>
+            <a:pPr algn="ctr"/>
+          </a:p>
+        </p:txBody>
+      </p:sp>
+      <p:sp>
+        <p:nvSpPr>
+          <p:cNvPr id="78" name="TextBox 77"/>
+          <p:cNvSpPr txBox="1"/>
+          <p:nvPr/>
+        </p:nvSpPr>
+        <p:spPr>
+          <a:xfrm>
+            <a:off x="11183112" y="3977639"/>
+            <a:ext cx="310896" cy="310896"/>
+          </a:xfrm>
+          <a:prstGeom prst="rect">
+            <a:avLst/>
+          </a:prstGeom>
+          <a:noFill/>
+        </p:spPr>
+        <p:txBody>
+          <a:bodyPr wrap="none" lIns="0" rIns="0" tIns="0" bIns="0">
+            <a:spAutoFit/>
+          </a:bodyPr>
+          <a:lstStyle/>
+          <a:p>
+            <a:pPr algn="ctr">
+              <a:lnSpc>
+                <a:spcPts val="2196"/>
+              </a:lnSpc>
+              <a:spcBef>
+                <a:spcPts val="0"/>
+              </a:spcBef>
+              <a:spcAft>
+                <a:spcPts val="0"/>
+              </a:spcAft>
+              <a:defRPr sz="1800" b="0">
+                <a:solidFill>
+                  <a:srgbClr val="087F8C"/>
+                </a:solidFill>
+                <a:latin typeface="Arial Unicode MS"/>
+              </a:defRPr>
+            </a:pPr>
+            <a:r>
+              <a:t>h</a:t>
+            </a:r>
+          </a:p>
+        </p:txBody>
+      </p:sp>
+      <p:cxnSp>
+        <p:nvCxnSpPr>
+          <p:cNvPr id="79" name="Connector 78"/>
+          <p:cNvCxnSpPr/>
+          <p:nvPr/>
+        </p:nvCxnSpPr>
+        <p:spPr>
+          <a:xfrm>
+            <a:off x="8970264" y="5148072"/>
+            <a:ext cx="0" cy="173736"/>
+          </a:xfrm>
+          <a:prstGeom prst="line">
+            <a:avLst/>
+          </a:prstGeom>
+          <a:ln w="21590">
+            <a:solidFill>
+              <a:srgbClr val="087F8C"/>
+            </a:solidFill>
+          </a:ln>
+        </p:spPr>
+        <p:style>
+          <a:lnRef idx="2">
+            <a:schemeClr val="accent1"/>
+          </a:lnRef>
+          <a:fillRef idx="0">
+            <a:schemeClr val="accent1"/>
+          </a:fillRef>
+          <a:effectRef idx="1">
+            <a:schemeClr val="accent1"/>
+          </a:effectRef>
+          <a:fontRef idx="minor">
+            <a:schemeClr val="tx1"/>
+          </a:fontRef>
+        </p:style>
+      </p:cxnSp>
+      <p:sp>
+        <p:nvSpPr>
+          <p:cNvPr id="80" name="Isosceles Triangle 79"/>
+          <p:cNvSpPr/>
+          <p:nvPr/>
+        </p:nvSpPr>
+        <p:spPr>
+          <a:xfrm rot="10800000">
+            <a:off x="8938260" y="5280660"/>
+            <a:ext cx="64008" cy="82296"/>
+          </a:xfrm>
+          <a:prstGeom prst="triangle">
+            <a:avLst/>
+          </a:prstGeom>
+          <a:solidFill>
+            <a:srgbClr val="087F8C"/>
+          </a:solidFill>
+          <a:ln>
+            <a:noFill/>
+          </a:ln>
+        </p:spPr>
+        <p:style>
+          <a:lnRef idx="1">
+            <a:schemeClr val="accent1"/>
+          </a:lnRef>
+          <a:fillRef idx="3">
+            <a:schemeClr val="accent1"/>
+          </a:fillRef>
+          <a:effectRef idx="2">
+            <a:schemeClr val="accent1"/>
+          </a:effectRef>
+          <a:fontRef idx="minor">
+            <a:schemeClr val="lt1"/>
+          </a:fontRef>
+        </p:style>
+        <p:txBody>
+          <a:bodyPr rtlCol="0" anchor="ctr"/>
+          <a:lstStyle/>
+          <a:p>
+            <a:pPr algn="ctr"/>
+          </a:p>
+        </p:txBody>
+      </p:sp>
+      <p:sp>
+        <p:nvSpPr>
+          <p:cNvPr id="81" name="TextBox 80"/>
+          <p:cNvSpPr txBox="1"/>
+          <p:nvPr/>
+        </p:nvSpPr>
+        <p:spPr>
+          <a:xfrm>
+            <a:off x="7086600" y="5404104"/>
+            <a:ext cx="3794760" cy="301752"/>
+          </a:xfrm>
+          <a:prstGeom prst="rect">
+            <a:avLst/>
+          </a:prstGeom>
+          <a:noFill/>
+        </p:spPr>
+        <p:txBody>
+          <a:bodyPr wrap="none" lIns="0" rIns="0" tIns="0" bIns="0">
+            <a:spAutoFit/>
+          </a:bodyPr>
+          <a:lstStyle/>
+          <a:p>
+            <a:pPr algn="ctr">
+              <a:lnSpc>
+                <a:spcPts val="2196"/>
+              </a:lnSpc>
+              <a:spcBef>
+                <a:spcPts val="0"/>
+              </a:spcBef>
+              <a:spcAft>
+                <a:spcPts val="0"/>
+              </a:spcAft>
+              <a:defRPr sz="1800" b="0">
+                <a:solidFill>
+                  <a:srgbClr val="475569"/>
+                </a:solidFill>
+                <a:latin typeface="Arial Unicode MS"/>
+              </a:defRPr>
+            </a:pPr>
+            <a:r>
+              <a:t>输出仍为 [B,T,D]，再送下一层。</a:t>
+            </a:r>
+          </a:p>
+        </p:txBody>
+      </p:sp>
+      <p:sp>
+        <p:nvSpPr>
+          <p:cNvPr id="82" name="TextBox 81"/>
+          <p:cNvSpPr txBox="1"/>
+          <p:nvPr/>
+        </p:nvSpPr>
+        <p:spPr>
+          <a:xfrm>
+            <a:off x="731520" y="5824728"/>
+            <a:ext cx="10698480" cy="278892"/>
           </a:xfrm>
           <a:prstGeom prst="rect">
             <a:avLst/>
@@ -7432,214 +9524,13 @@
               </a:spcAft>
               <a:defRPr sz="1800" b="0">
                 <a:solidFill>
-                  <a:srgbClr val="14263D"/>
-                </a:solidFill>
-                <a:latin typeface="Arial Unicode MS"/>
-              </a:defRPr>
-            </a:pPr>
-            <a:r>
-              <a:t>模型计算候选 token 的概率，通过</a:t>
-            </a:r>
-          </a:p>
-          <a:p>
-            <a:pPr>
-              <a:lnSpc>
-                <a:spcPts val="2196"/>
-              </a:lnSpc>
-              <a:spcBef>
-                <a:spcPts val="0"/>
-              </a:spcBef>
-              <a:spcAft>
-                <a:spcPts val="0"/>
-              </a:spcAft>
-              <a:defRPr sz="1800" b="0">
-                <a:solidFill>
-                  <a:srgbClr val="14263D"/>
-                </a:solidFill>
-                <a:latin typeface="Arial Unicode MS"/>
-              </a:defRPr>
-            </a:pPr>
-            <a:r>
-              <a:t>预测误差调整参数。</a:t>
-            </a:r>
-          </a:p>
-        </p:txBody>
-      </p:sp>
-      <p:sp>
-        <p:nvSpPr>
-          <p:cNvPr id="31" name="TextBox 30"/>
-          <p:cNvSpPr txBox="1"/>
-          <p:nvPr/>
-        </p:nvSpPr>
-        <p:spPr>
-          <a:xfrm>
-            <a:off x="7680960" y="3072384"/>
-            <a:ext cx="3685032" cy="571500"/>
-          </a:xfrm>
-          <a:prstGeom prst="rect">
-            <a:avLst/>
-          </a:prstGeom>
-          <a:noFill/>
-        </p:spPr>
-        <p:txBody>
-          <a:bodyPr wrap="none" lIns="0" rIns="0" tIns="0" bIns="0">
-            <a:spAutoFit/>
-          </a:bodyPr>
-          <a:lstStyle/>
-          <a:p>
-            <a:pPr>
-              <a:lnSpc>
-                <a:spcPts val="2196"/>
-              </a:lnSpc>
-              <a:spcBef>
-                <a:spcPts val="0"/>
-              </a:spcBef>
-              <a:spcAft>
-                <a:spcPts val="0"/>
-              </a:spcAft>
-              <a:defRPr sz="1800" b="0">
-                <a:solidFill>
-                  <a:srgbClr val="14263D"/>
-                </a:solidFill>
-                <a:latin typeface="Arial Unicode MS"/>
-              </a:defRPr>
-            </a:pPr>
-            <a:r>
-              <a:t>本课先看输入怎么构造；下一课再</a:t>
-            </a:r>
-          </a:p>
-          <a:p>
-            <a:pPr>
-              <a:lnSpc>
-                <a:spcPts val="2196"/>
-              </a:lnSpc>
-              <a:spcBef>
-                <a:spcPts val="0"/>
-              </a:spcBef>
-              <a:spcAft>
-                <a:spcPts val="0"/>
-              </a:spcAft>
-              <a:defRPr sz="1800" b="0">
-                <a:solidFill>
-                  <a:srgbClr val="14263D"/>
-                </a:solidFill>
-                <a:latin typeface="Arial Unicode MS"/>
-              </a:defRPr>
-            </a:pPr>
-            <a:r>
-              <a:t>深入信息怎样在 token 之间交互。</a:t>
-            </a:r>
-          </a:p>
-        </p:txBody>
-      </p:sp>
-      <p:sp>
-        <p:nvSpPr>
-          <p:cNvPr id="32" name="TextBox 31"/>
-          <p:cNvSpPr txBox="1"/>
-          <p:nvPr/>
-        </p:nvSpPr>
-        <p:spPr>
-          <a:xfrm>
-            <a:off x="7680960" y="3694176"/>
-            <a:ext cx="3685032" cy="571500"/>
-          </a:xfrm>
-          <a:prstGeom prst="rect">
-            <a:avLst/>
-          </a:prstGeom>
-          <a:noFill/>
-        </p:spPr>
-        <p:txBody>
-          <a:bodyPr wrap="none" lIns="0" rIns="0" tIns="0" bIns="0">
-            <a:spAutoFit/>
-          </a:bodyPr>
-          <a:lstStyle/>
-          <a:p>
-            <a:pPr>
-              <a:lnSpc>
-                <a:spcPts val="2196"/>
-              </a:lnSpc>
-              <a:spcBef>
-                <a:spcPts val="0"/>
-              </a:spcBef>
-              <a:spcAft>
-                <a:spcPts val="0"/>
-              </a:spcAft>
-              <a:defRPr sz="1800" b="0">
-                <a:solidFill>
-                  <a:srgbClr val="14263D"/>
-                </a:solidFill>
-                <a:latin typeface="Arial Unicode MS"/>
-              </a:defRPr>
-            </a:pPr>
-            <a:r>
-              <a:t>B=句子数，T=序列长度，V=词表项</a:t>
-            </a:r>
-          </a:p>
-          <a:p>
-            <a:pPr>
-              <a:lnSpc>
-                <a:spcPts val="2196"/>
-              </a:lnSpc>
-              <a:spcBef>
-                <a:spcPts val="0"/>
-              </a:spcBef>
-              <a:spcAft>
-                <a:spcPts val="0"/>
-              </a:spcAft>
-              <a:defRPr sz="1800" b="0">
-                <a:solidFill>
-                  <a:srgbClr val="14263D"/>
-                </a:solidFill>
-                <a:latin typeface="Arial Unicode MS"/>
-              </a:defRPr>
-            </a:pPr>
-            <a:r>
-              <a:t>数，D=向量维度。</a:t>
-            </a:r>
-          </a:p>
-        </p:txBody>
-      </p:sp>
-      <p:sp>
-        <p:nvSpPr>
-          <p:cNvPr id="33" name="TextBox 32"/>
-          <p:cNvSpPr txBox="1"/>
-          <p:nvPr/>
-        </p:nvSpPr>
-        <p:spPr>
-          <a:xfrm>
-            <a:off x="786384" y="5175504"/>
-            <a:ext cx="10607040" cy="484632"/>
-          </a:xfrm>
-          <a:prstGeom prst="rect">
-            <a:avLst/>
-          </a:prstGeom>
-          <a:noFill/>
-        </p:spPr>
-        <p:txBody>
-          <a:bodyPr wrap="none" lIns="0" rIns="0" tIns="0" bIns="0">
-            <a:spAutoFit/>
-          </a:bodyPr>
-          <a:lstStyle/>
-          <a:p>
-            <a:pPr>
-              <a:lnSpc>
-                <a:spcPts val="2806"/>
-              </a:lnSpc>
-              <a:spcBef>
-                <a:spcPts val="0"/>
-              </a:spcBef>
-              <a:spcAft>
-                <a:spcPts val="0"/>
-              </a:spcAft>
-              <a:defRPr sz="2300" b="1">
-                <a:solidFill>
-                  <a:srgbClr val="2458C6"/>
-                </a:solidFill>
-                <a:latin typeface="Arial Unicode MS"/>
-              </a:defRPr>
-            </a:pPr>
-            <a:r>
-              <a:t>三件事：规则决定读哪些片段；参数学习怎么表示；位置补上顺序关系。</a:t>
+                  <a:srgbClr val="475569"/>
+                </a:solidFill>
+                <a:latin typeface="Arial Unicode MS"/>
+              </a:defRPr>
+            </a:pPr>
+            <a:r>
+              <a:t>B：句子数；T：token数；D：每个token的向量维度；V：词表大小。</a:t>
             </a:r>
           </a:p>
         </p:txBody>
@@ -23031,7 +24922,7 @@
               </a:defRPr>
             </a:pPr>
             <a:r>
-              <a:t>分得更细，还是词表更大？</a:t>
+              <a:t>从上节课的计算，走到今天的输入端</a:t>
             </a:r>
           </a:p>
         </p:txBody>
@@ -23076,7 +24967,7 @@
               </a:defRPr>
             </a:pPr>
             <a:r>
-              <a:t>词表大小 V 与序列长度 T，会影响不同部分的计算成本。</a:t>
+              <a:t>上节课算过 Q/K 匹配、加权混合 V 和候选选择；今天补充分词、向量与位置。</a:t>
             </a:r>
           </a:p>
         </p:txBody>
@@ -23166,7 +25057,7 @@
               </a:defRPr>
             </a:pPr>
             <a:r>
-              <a:t>选择切分粒度，也是在选择参数与计算的开销。</a:t>
+              <a:t>本课聚焦：Tokenizer、Embedding、位置编码在整体架构中的作用。</a:t>
             </a:r>
           </a:p>
         </p:txBody>
@@ -23270,7 +25161,7 @@
         <p:spPr>
           <a:xfrm>
             <a:off x="548640" y="1901952"/>
-            <a:ext cx="11064240" cy="2468880"/>
+            <a:ext cx="11064240" cy="1143000"/>
           </a:xfrm>
           <a:prstGeom prst="roundRect">
             <a:avLst>
@@ -23346,7 +25237,7 @@
               </a:defRPr>
             </a:pPr>
             <a:r>
-              <a:t>同一句“我喜欢喝奶茶”：不同切分粒度的取舍（示意）</a:t>
+              <a:t>上节课的人工算例：“我 / 喜欢 / 喝” → 下一 token</a:t>
             </a:r>
           </a:p>
         </p:txBody>
@@ -23359,8 +25250,8 @@
         </p:nvSpPr>
         <p:spPr>
           <a:xfrm>
-            <a:off x="777240" y="2487168"/>
-            <a:ext cx="1371600" cy="347472"/>
+            <a:off x="777240" y="2395728"/>
+            <a:ext cx="10588752" cy="325374"/>
           </a:xfrm>
           <a:prstGeom prst="rect">
             <a:avLst/>
@@ -23375,15 +25266,60 @@
           <a:p>
             <a:pPr>
               <a:lnSpc>
-                <a:spcPts val="2684"/>
-              </a:lnSpc>
-              <a:spcBef>
-                <a:spcPts val="0"/>
-              </a:spcBef>
-              <a:spcAft>
-                <a:spcPts val="0"/>
-              </a:spcAft>
-              <a:defRPr sz="2200" b="1">
+                <a:spcPts val="2562"/>
+              </a:lnSpc>
+              <a:spcBef>
+                <a:spcPts val="0"/>
+              </a:spcBef>
+              <a:spcAft>
+                <a:spcPts val="0"/>
+              </a:spcAft>
+              <a:defRPr sz="2100" b="0">
+                <a:solidFill>
+                  <a:srgbClr val="14263D"/>
+                </a:solidFill>
+                <a:latin typeface="Arial Unicode MS"/>
+              </a:defRPr>
+            </a:pPr>
+            <a:r>
+              <a:t>Q/K 匹配 → Softmax 权重 ≈ [0.248,0.248,0.503] → 加权混合 V</a:t>
+            </a:r>
+          </a:p>
+        </p:txBody>
+      </p:sp>
+      <p:sp>
+        <p:nvSpPr>
+          <p:cNvPr id="19" name="TextBox 18"/>
+          <p:cNvSpPr txBox="1"/>
+          <p:nvPr/>
+        </p:nvSpPr>
+        <p:spPr>
+          <a:xfrm>
+            <a:off x="777240" y="2761488"/>
+            <a:ext cx="10588752" cy="294386"/>
+          </a:xfrm>
+          <a:prstGeom prst="rect">
+            <a:avLst/>
+          </a:prstGeom>
+          <a:noFill/>
+        </p:spPr>
+        <p:txBody>
+          <a:bodyPr wrap="none" lIns="0" rIns="0" tIns="0" bIns="0">
+            <a:spAutoFit/>
+          </a:bodyPr>
+          <a:lstStyle/>
+          <a:p>
+            <a:pPr>
+              <a:lnSpc>
+                <a:spcPts val="2318"/>
+              </a:lnSpc>
+              <a:spcBef>
+                <a:spcPts val="0"/>
+              </a:spcBef>
+              <a:spcAft>
+                <a:spcPts val="0"/>
+              </a:spcAft>
+              <a:defRPr sz="1900" b="0">
                 <a:solidFill>
                   <a:srgbClr val="2458C6"/>
                 </a:solidFill>
@@ -23391,561 +25327,21 @@
               </a:defRPr>
             </a:pPr>
             <a:r>
-              <a:t>按字</a:t>
-            </a:r>
-          </a:p>
-        </p:txBody>
-      </p:sp>
-      <p:sp>
-        <p:nvSpPr>
-          <p:cNvPr id="19" name="TextBox 18"/>
-          <p:cNvSpPr txBox="1"/>
-          <p:nvPr/>
-        </p:nvSpPr>
-        <p:spPr>
-          <a:xfrm>
-            <a:off x="2286000" y="2487168"/>
-            <a:ext cx="4114800" cy="347472"/>
-          </a:xfrm>
-          <a:prstGeom prst="rect">
-            <a:avLst/>
-          </a:prstGeom>
-          <a:noFill/>
-        </p:spPr>
-        <p:txBody>
-          <a:bodyPr wrap="none" lIns="0" rIns="0" tIns="0" bIns="0">
-            <a:spAutoFit/>
-          </a:bodyPr>
-          <a:lstStyle/>
-          <a:p>
-            <a:pPr>
-              <a:lnSpc>
-                <a:spcPts val="2562"/>
-              </a:lnSpc>
-              <a:spcBef>
-                <a:spcPts val="0"/>
-              </a:spcBef>
-              <a:spcAft>
-                <a:spcPts val="0"/>
-              </a:spcAft>
-              <a:defRPr sz="2100" b="0">
-                <a:solidFill>
-                  <a:srgbClr val="14263D"/>
-                </a:solidFill>
-                <a:latin typeface="Arial Unicode MS"/>
-              </a:defRPr>
-            </a:pPr>
-            <a:r>
-              <a:t>我 / 喜 / 欢 / 喝 / 奶 / 茶</a:t>
-            </a:r>
-          </a:p>
-        </p:txBody>
-      </p:sp>
-      <p:sp>
-        <p:nvSpPr>
-          <p:cNvPr id="20" name="TextBox 19"/>
-          <p:cNvSpPr txBox="1"/>
-          <p:nvPr/>
-        </p:nvSpPr>
-        <p:spPr>
-          <a:xfrm>
-            <a:off x="6583680" y="2487168"/>
-            <a:ext cx="1005840" cy="347472"/>
-          </a:xfrm>
-          <a:prstGeom prst="rect">
-            <a:avLst/>
-          </a:prstGeom>
-          <a:noFill/>
-        </p:spPr>
-        <p:txBody>
-          <a:bodyPr wrap="none" lIns="0" rIns="0" tIns="0" bIns="0">
-            <a:spAutoFit/>
-          </a:bodyPr>
-          <a:lstStyle/>
-          <a:p>
-            <a:pPr>
-              <a:lnSpc>
-                <a:spcPts val="2684"/>
-              </a:lnSpc>
-              <a:spcBef>
-                <a:spcPts val="0"/>
-              </a:spcBef>
-              <a:spcAft>
-                <a:spcPts val="0"/>
-              </a:spcAft>
-              <a:defRPr sz="2200" b="0">
-                <a:solidFill>
-                  <a:srgbClr val="087F8C"/>
-                </a:solidFill>
-                <a:latin typeface="Arial Unicode MS"/>
-              </a:defRPr>
-            </a:pPr>
-            <a:r>
-              <a:t>6项</a:t>
-            </a:r>
-          </a:p>
-        </p:txBody>
-      </p:sp>
-      <p:sp>
-        <p:nvSpPr>
-          <p:cNvPr id="21" name="TextBox 20"/>
-          <p:cNvSpPr txBox="1"/>
-          <p:nvPr/>
-        </p:nvSpPr>
-        <p:spPr>
-          <a:xfrm>
-            <a:off x="7772400" y="2487168"/>
-            <a:ext cx="3566160" cy="365760"/>
-          </a:xfrm>
-          <a:prstGeom prst="rect">
-            <a:avLst/>
-          </a:prstGeom>
-          <a:noFill/>
-        </p:spPr>
-        <p:txBody>
-          <a:bodyPr wrap="none" lIns="0" rIns="0" tIns="0" bIns="0">
-            <a:spAutoFit/>
-          </a:bodyPr>
-          <a:lstStyle/>
-          <a:p>
-            <a:pPr>
-              <a:lnSpc>
-                <a:spcPts val="2318"/>
-              </a:lnSpc>
-              <a:spcBef>
-                <a:spcPts val="0"/>
-              </a:spcBef>
-              <a:spcAft>
-                <a:spcPts val="0"/>
-              </a:spcAft>
-              <a:defRPr sz="1900" b="0">
-                <a:solidFill>
-                  <a:srgbClr val="475569"/>
-                </a:solidFill>
-                <a:latin typeface="Arial Unicode MS"/>
-              </a:defRPr>
-            </a:pPr>
-            <a:r>
-              <a:t>片段短，序列更长</a:t>
-            </a:r>
-          </a:p>
-        </p:txBody>
-      </p:sp>
-      <p:sp>
-        <p:nvSpPr>
-          <p:cNvPr id="22" name="TextBox 21"/>
-          <p:cNvSpPr txBox="1"/>
-          <p:nvPr/>
-        </p:nvSpPr>
-        <p:spPr>
-          <a:xfrm>
-            <a:off x="777240" y="3017520"/>
-            <a:ext cx="1371600" cy="347472"/>
-          </a:xfrm>
-          <a:prstGeom prst="rect">
-            <a:avLst/>
-          </a:prstGeom>
-          <a:noFill/>
-        </p:spPr>
-        <p:txBody>
-          <a:bodyPr wrap="none" lIns="0" rIns="0" tIns="0" bIns="0">
-            <a:spAutoFit/>
-          </a:bodyPr>
-          <a:lstStyle/>
-          <a:p>
-            <a:pPr>
-              <a:lnSpc>
-                <a:spcPts val="2684"/>
-              </a:lnSpc>
-              <a:spcBef>
-                <a:spcPts val="0"/>
-              </a:spcBef>
-              <a:spcAft>
-                <a:spcPts val="0"/>
-              </a:spcAft>
-              <a:defRPr sz="2200" b="1">
-                <a:solidFill>
-                  <a:srgbClr val="2458C6"/>
-                </a:solidFill>
-                <a:latin typeface="Arial Unicode MS"/>
-              </a:defRPr>
-            </a:pPr>
-            <a:r>
-              <a:t>按整词</a:t>
-            </a:r>
-          </a:p>
-        </p:txBody>
-      </p:sp>
-      <p:sp>
-        <p:nvSpPr>
-          <p:cNvPr id="23" name="TextBox 22"/>
-          <p:cNvSpPr txBox="1"/>
-          <p:nvPr/>
-        </p:nvSpPr>
-        <p:spPr>
-          <a:xfrm>
-            <a:off x="2286000" y="3017520"/>
-            <a:ext cx="4114800" cy="347472"/>
-          </a:xfrm>
-          <a:prstGeom prst="rect">
-            <a:avLst/>
-          </a:prstGeom>
-          <a:noFill/>
-        </p:spPr>
-        <p:txBody>
-          <a:bodyPr wrap="none" lIns="0" rIns="0" tIns="0" bIns="0">
-            <a:spAutoFit/>
-          </a:bodyPr>
-          <a:lstStyle/>
-          <a:p>
-            <a:pPr>
-              <a:lnSpc>
-                <a:spcPts val="2562"/>
-              </a:lnSpc>
-              <a:spcBef>
-                <a:spcPts val="0"/>
-              </a:spcBef>
-              <a:spcAft>
-                <a:spcPts val="0"/>
-              </a:spcAft>
-              <a:defRPr sz="2100" b="0">
-                <a:solidFill>
-                  <a:srgbClr val="14263D"/>
-                </a:solidFill>
-                <a:latin typeface="Arial Unicode MS"/>
-              </a:defRPr>
-            </a:pPr>
-            <a:r>
-              <a:t>我 / 喜欢 / 喝 / 奶茶</a:t>
-            </a:r>
-          </a:p>
-        </p:txBody>
-      </p:sp>
-      <p:sp>
-        <p:nvSpPr>
-          <p:cNvPr id="24" name="TextBox 23"/>
-          <p:cNvSpPr txBox="1"/>
-          <p:nvPr/>
-        </p:nvSpPr>
-        <p:spPr>
-          <a:xfrm>
-            <a:off x="6583680" y="3017520"/>
-            <a:ext cx="1005840" cy="347472"/>
-          </a:xfrm>
-          <a:prstGeom prst="rect">
-            <a:avLst/>
-          </a:prstGeom>
-          <a:noFill/>
-        </p:spPr>
-        <p:txBody>
-          <a:bodyPr wrap="none" lIns="0" rIns="0" tIns="0" bIns="0">
-            <a:spAutoFit/>
-          </a:bodyPr>
-          <a:lstStyle/>
-          <a:p>
-            <a:pPr>
-              <a:lnSpc>
-                <a:spcPts val="2684"/>
-              </a:lnSpc>
-              <a:spcBef>
-                <a:spcPts val="0"/>
-              </a:spcBef>
-              <a:spcAft>
-                <a:spcPts val="0"/>
-              </a:spcAft>
-              <a:defRPr sz="2200" b="0">
-                <a:solidFill>
-                  <a:srgbClr val="087F8C"/>
-                </a:solidFill>
-                <a:latin typeface="Arial Unicode MS"/>
-              </a:defRPr>
-            </a:pPr>
-            <a:r>
-              <a:t>4项</a:t>
-            </a:r>
-          </a:p>
-        </p:txBody>
-      </p:sp>
-      <p:sp>
-        <p:nvSpPr>
-          <p:cNvPr id="25" name="TextBox 24"/>
-          <p:cNvSpPr txBox="1"/>
-          <p:nvPr/>
-        </p:nvSpPr>
-        <p:spPr>
-          <a:xfrm>
-            <a:off x="7772400" y="3017520"/>
-            <a:ext cx="3566160" cy="365760"/>
-          </a:xfrm>
-          <a:prstGeom prst="rect">
-            <a:avLst/>
-          </a:prstGeom>
-          <a:noFill/>
-        </p:spPr>
-        <p:txBody>
-          <a:bodyPr wrap="none" lIns="0" rIns="0" tIns="0" bIns="0">
-            <a:spAutoFit/>
-          </a:bodyPr>
-          <a:lstStyle/>
-          <a:p>
-            <a:pPr>
-              <a:lnSpc>
-                <a:spcPts val="2318"/>
-              </a:lnSpc>
-              <a:spcBef>
-                <a:spcPts val="0"/>
-              </a:spcBef>
-              <a:spcAft>
-                <a:spcPts val="0"/>
-              </a:spcAft>
-              <a:defRPr sz="1900" b="0">
-                <a:solidFill>
-                  <a:srgbClr val="475569"/>
-                </a:solidFill>
-                <a:latin typeface="Arial Unicode MS"/>
-              </a:defRPr>
-            </a:pPr>
-            <a:r>
-              <a:t>需要词边界，词表可能更大</a:t>
-            </a:r>
-          </a:p>
-        </p:txBody>
-      </p:sp>
-      <p:sp>
-        <p:nvSpPr>
-          <p:cNvPr id="26" name="TextBox 25"/>
-          <p:cNvSpPr txBox="1"/>
-          <p:nvPr/>
-        </p:nvSpPr>
-        <p:spPr>
-          <a:xfrm>
-            <a:off x="777240" y="3547872"/>
-            <a:ext cx="1371600" cy="347472"/>
-          </a:xfrm>
-          <a:prstGeom prst="rect">
-            <a:avLst/>
-          </a:prstGeom>
-          <a:noFill/>
-        </p:spPr>
-        <p:txBody>
-          <a:bodyPr wrap="none" lIns="0" rIns="0" tIns="0" bIns="0">
-            <a:spAutoFit/>
-          </a:bodyPr>
-          <a:lstStyle/>
-          <a:p>
-            <a:pPr>
-              <a:lnSpc>
-                <a:spcPts val="2684"/>
-              </a:lnSpc>
-              <a:spcBef>
-                <a:spcPts val="0"/>
-              </a:spcBef>
-              <a:spcAft>
-                <a:spcPts val="0"/>
-              </a:spcAft>
-              <a:defRPr sz="2200" b="1">
-                <a:solidFill>
-                  <a:srgbClr val="2458C6"/>
-                </a:solidFill>
-                <a:latin typeface="Arial Unicode MS"/>
-              </a:defRPr>
-            </a:pPr>
-            <a:r>
-              <a:t>本例 BPE</a:t>
-            </a:r>
-          </a:p>
-        </p:txBody>
-      </p:sp>
-      <p:sp>
-        <p:nvSpPr>
-          <p:cNvPr id="27" name="TextBox 26"/>
-          <p:cNvSpPr txBox="1"/>
-          <p:nvPr/>
-        </p:nvSpPr>
-        <p:spPr>
-          <a:xfrm>
-            <a:off x="2286000" y="3547872"/>
-            <a:ext cx="4114800" cy="347472"/>
-          </a:xfrm>
-          <a:prstGeom prst="rect">
-            <a:avLst/>
-          </a:prstGeom>
-          <a:noFill/>
-        </p:spPr>
-        <p:txBody>
-          <a:bodyPr wrap="none" lIns="0" rIns="0" tIns="0" bIns="0">
-            <a:spAutoFit/>
-          </a:bodyPr>
-          <a:lstStyle/>
-          <a:p>
-            <a:pPr>
-              <a:lnSpc>
-                <a:spcPts val="2562"/>
-              </a:lnSpc>
-              <a:spcBef>
-                <a:spcPts val="0"/>
-              </a:spcBef>
-              <a:spcAft>
-                <a:spcPts val="0"/>
-              </a:spcAft>
-              <a:defRPr sz="2100" b="0">
-                <a:solidFill>
-                  <a:srgbClr val="14263D"/>
-                </a:solidFill>
-                <a:latin typeface="Arial Unicode MS"/>
-              </a:defRPr>
-            </a:pPr>
-            <a:r>
-              <a:t>我 / 喜欢喝奶茶</a:t>
-            </a:r>
-          </a:p>
-        </p:txBody>
-      </p:sp>
-      <p:sp>
-        <p:nvSpPr>
-          <p:cNvPr id="28" name="TextBox 27"/>
-          <p:cNvSpPr txBox="1"/>
-          <p:nvPr/>
-        </p:nvSpPr>
-        <p:spPr>
-          <a:xfrm>
-            <a:off x="6583680" y="3547872"/>
-            <a:ext cx="1005840" cy="347472"/>
-          </a:xfrm>
-          <a:prstGeom prst="rect">
-            <a:avLst/>
-          </a:prstGeom>
-          <a:noFill/>
-        </p:spPr>
-        <p:txBody>
-          <a:bodyPr wrap="none" lIns="0" rIns="0" tIns="0" bIns="0">
-            <a:spAutoFit/>
-          </a:bodyPr>
-          <a:lstStyle/>
-          <a:p>
-            <a:pPr>
-              <a:lnSpc>
-                <a:spcPts val="2684"/>
-              </a:lnSpc>
-              <a:spcBef>
-                <a:spcPts val="0"/>
-              </a:spcBef>
-              <a:spcAft>
-                <a:spcPts val="0"/>
-              </a:spcAft>
-              <a:defRPr sz="2200" b="0">
-                <a:solidFill>
-                  <a:srgbClr val="087F8C"/>
-                </a:solidFill>
-                <a:latin typeface="Arial Unicode MS"/>
-              </a:defRPr>
-            </a:pPr>
-            <a:r>
-              <a:t>2项</a:t>
-            </a:r>
-          </a:p>
-        </p:txBody>
-      </p:sp>
-      <p:sp>
-        <p:nvSpPr>
-          <p:cNvPr id="29" name="TextBox 28"/>
-          <p:cNvSpPr txBox="1"/>
-          <p:nvPr/>
-        </p:nvSpPr>
-        <p:spPr>
-          <a:xfrm>
-            <a:off x="7772400" y="3547872"/>
-            <a:ext cx="3566160" cy="365760"/>
-          </a:xfrm>
-          <a:prstGeom prst="rect">
-            <a:avLst/>
-          </a:prstGeom>
-          <a:noFill/>
-        </p:spPr>
-        <p:txBody>
-          <a:bodyPr wrap="none" lIns="0" rIns="0" tIns="0" bIns="0">
-            <a:spAutoFit/>
-          </a:bodyPr>
-          <a:lstStyle/>
-          <a:p>
-            <a:pPr>
-              <a:lnSpc>
-                <a:spcPts val="2318"/>
-              </a:lnSpc>
-              <a:spcBef>
-                <a:spcPts val="0"/>
-              </a:spcBef>
-              <a:spcAft>
-                <a:spcPts val="0"/>
-              </a:spcAft>
-              <a:defRPr sz="1900" b="0">
-                <a:solidFill>
-                  <a:srgbClr val="475569"/>
-                </a:solidFill>
-                <a:latin typeface="Arial Unicode MS"/>
-              </a:defRPr>
-            </a:pPr>
-            <a:r>
-              <a:t>高频合并，新组合复用片段</a:t>
-            </a:r>
-          </a:p>
-        </p:txBody>
-      </p:sp>
-      <p:sp>
-        <p:nvSpPr>
-          <p:cNvPr id="30" name="TextBox 29"/>
-          <p:cNvSpPr txBox="1"/>
-          <p:nvPr/>
-        </p:nvSpPr>
-        <p:spPr>
-          <a:xfrm>
-            <a:off x="768096" y="4050791"/>
-            <a:ext cx="10561320" cy="278892"/>
-          </a:xfrm>
-          <a:prstGeom prst="rect">
-            <a:avLst/>
-          </a:prstGeom>
-          <a:noFill/>
-        </p:spPr>
-        <p:txBody>
-          <a:bodyPr wrap="none" lIns="0" rIns="0" tIns="0" bIns="0">
-            <a:spAutoFit/>
-          </a:bodyPr>
-          <a:lstStyle/>
-          <a:p>
-            <a:pPr>
-              <a:lnSpc>
-                <a:spcPts val="2196"/>
-              </a:lnSpc>
-              <a:spcBef>
-                <a:spcPts val="0"/>
-              </a:spcBef>
-              <a:spcAft>
-                <a:spcPts val="0"/>
-              </a:spcAft>
-              <a:defRPr sz="1800" b="0">
-                <a:solidFill>
-                  <a:srgbClr val="475569"/>
-                </a:solidFill>
-                <a:latin typeface="Arial Unicode MS"/>
-              </a:defRPr>
-            </a:pPr>
-            <a:r>
-              <a:t>BPE 的 2 项来自后面奶茶小语料的4次合并，不代表商用模型一定这样切。</a:t>
-            </a:r>
-          </a:p>
-        </p:txBody>
-      </p:sp>
-      <p:sp>
-        <p:nvSpPr>
-          <p:cNvPr id="31" name="Rounded Rectangle 30"/>
+              <a:t>混合向量 ≈ [0.752,0.752] → 输出映射 → 酒 / 牛奶的概率 ≈ [0.680,0.320]</a:t>
+            </a:r>
+          </a:p>
+        </p:txBody>
+      </p:sp>
+      <p:sp>
+        <p:nvSpPr>
+          <p:cNvPr id="20" name="Rounded Rectangle 19"/>
           <p:cNvSpPr/>
           <p:nvPr/>
         </p:nvSpPr>
         <p:spPr>
           <a:xfrm>
-            <a:off x="548640" y="4553712"/>
-            <a:ext cx="5440680" cy="1143000"/>
+            <a:off x="548640" y="3246120"/>
+            <a:ext cx="3566160" cy="2194560"/>
           </a:xfrm>
           <a:prstGeom prst="roundRect">
             <a:avLst>
@@ -23983,14 +25379,14 @@
       </p:sp>
       <p:sp>
         <p:nvSpPr>
-          <p:cNvPr id="32" name="TextBox 31"/>
-          <p:cNvSpPr txBox="1"/>
-          <p:nvPr/>
-        </p:nvSpPr>
-        <p:spPr>
-          <a:xfrm>
-            <a:off x="731520" y="4690872"/>
-            <a:ext cx="5074920" cy="283464"/>
+          <p:cNvPr id="21" name="TextBox 20"/>
+          <p:cNvSpPr txBox="1"/>
+          <p:nvPr/>
+        </p:nvSpPr>
+        <p:spPr>
+          <a:xfrm>
+            <a:off x="731520" y="3383279"/>
+            <a:ext cx="3200400" cy="283464"/>
           </a:xfrm>
           <a:prstGeom prst="rect">
             <a:avLst/>
@@ -24021,21 +25417,21 @@
               </a:defRPr>
             </a:pPr>
             <a:r>
-              <a:t>单份 E：D=4096，FP16，每参数2字节</a:t>
-            </a:r>
-          </a:p>
-        </p:txBody>
-      </p:sp>
-      <p:sp>
-        <p:nvSpPr>
-          <p:cNvPr id="33" name="TextBox 32"/>
-          <p:cNvSpPr txBox="1"/>
-          <p:nvPr/>
-        </p:nvSpPr>
-        <p:spPr>
-          <a:xfrm>
-            <a:off x="768096" y="5020056"/>
-            <a:ext cx="5001768" cy="475488"/>
+              <a:t>01  Tokenizer</a:t>
+            </a:r>
+          </a:p>
+        </p:txBody>
+      </p:sp>
+      <p:sp>
+        <p:nvSpPr>
+          <p:cNvPr id="22" name="TextBox 21"/>
+          <p:cNvSpPr txBox="1"/>
+          <p:nvPr/>
+        </p:nvSpPr>
+        <p:spPr>
+          <a:xfrm>
+            <a:off x="740664" y="3749039"/>
+            <a:ext cx="3182112" cy="603504"/>
           </a:xfrm>
           <a:prstGeom prst="rect">
             <a:avLst/>
@@ -24058,7 +25454,7 @@
               <a:spcAft>
                 <a:spcPts val="0"/>
               </a:spcAft>
-              <a:defRPr sz="2000" b="0">
+              <a:defRPr sz="2000" b="1">
                 <a:solidFill>
                   <a:srgbClr val="2458C6"/>
                 </a:solidFill>
@@ -24066,21 +25462,133 @@
               </a:defRPr>
             </a:pPr>
             <a:r>
-              <a:t>V=32k → 256 MiB；64k → 512 MiB</a:t>
-            </a:r>
-          </a:p>
-        </p:txBody>
-      </p:sp>
-      <p:sp>
-        <p:nvSpPr>
-          <p:cNvPr id="34" name="Rounded Rectangle 33"/>
+              <a:t>文本 → IDs [B,T]</a:t>
+            </a:r>
+          </a:p>
+        </p:txBody>
+      </p:sp>
+      <p:sp>
+        <p:nvSpPr>
+          <p:cNvPr id="23" name="TextBox 22"/>
+          <p:cNvSpPr txBox="1"/>
+          <p:nvPr/>
+        </p:nvSpPr>
+        <p:spPr>
+          <a:xfrm>
+            <a:off x="740664" y="4416552"/>
+            <a:ext cx="3182112" cy="292608"/>
+          </a:xfrm>
+          <a:prstGeom prst="rect">
+            <a:avLst/>
+          </a:prstGeom>
+          <a:noFill/>
+        </p:spPr>
+        <p:txBody>
+          <a:bodyPr wrap="none" lIns="0" rIns="0" tIns="0" bIns="0">
+            <a:spAutoFit/>
+          </a:bodyPr>
+          <a:lstStyle/>
+          <a:p>
+            <a:pPr>
+              <a:lnSpc>
+                <a:spcPts val="2196"/>
+              </a:lnSpc>
+              <a:spcBef>
+                <a:spcPts val="0"/>
+              </a:spcBef>
+              <a:spcAft>
+                <a:spcPts val="0"/>
+              </a:spcAft>
+              <a:defRPr sz="1800" b="0">
+                <a:solidFill>
+                  <a:srgbClr val="14263D"/>
+                </a:solidFill>
+                <a:latin typeface="Arial Unicode MS"/>
+              </a:defRPr>
+            </a:pPr>
+            <a:r>
+              <a:t>上节课：按空格切分。</a:t>
+            </a:r>
+          </a:p>
+        </p:txBody>
+      </p:sp>
+      <p:sp>
+        <p:nvSpPr>
+          <p:cNvPr id="24" name="TextBox 23"/>
+          <p:cNvSpPr txBox="1"/>
+          <p:nvPr/>
+        </p:nvSpPr>
+        <p:spPr>
+          <a:xfrm>
+            <a:off x="740664" y="4750308"/>
+            <a:ext cx="3182112" cy="571500"/>
+          </a:xfrm>
+          <a:prstGeom prst="rect">
+            <a:avLst/>
+          </a:prstGeom>
+          <a:noFill/>
+        </p:spPr>
+        <p:txBody>
+          <a:bodyPr wrap="none" lIns="0" rIns="0" tIns="0" bIns="0">
+            <a:spAutoFit/>
+          </a:bodyPr>
+          <a:lstStyle/>
+          <a:p>
+            <a:pPr>
+              <a:lnSpc>
+                <a:spcPts val="2196"/>
+              </a:lnSpc>
+              <a:spcBef>
+                <a:spcPts val="0"/>
+              </a:spcBef>
+              <a:spcAft>
+                <a:spcPts val="0"/>
+              </a:spcAft>
+              <a:defRPr sz="1800" b="0">
+                <a:solidFill>
+                  <a:srgbClr val="14263D"/>
+                </a:solidFill>
+                <a:latin typeface="Arial Unicode MS"/>
+              </a:defRPr>
+            </a:pPr>
+            <a:r>
+              <a:t>今天：BPE 怎样学规则、怎样</a:t>
+            </a:r>
+          </a:p>
+          <a:p>
+            <a:pPr>
+              <a:lnSpc>
+                <a:spcPts val="2196"/>
+              </a:lnSpc>
+              <a:spcBef>
+                <a:spcPts val="0"/>
+              </a:spcBef>
+              <a:spcAft>
+                <a:spcPts val="0"/>
+              </a:spcAft>
+              <a:defRPr sz="1800" b="0">
+                <a:solidFill>
+                  <a:srgbClr val="14263D"/>
+                </a:solidFill>
+                <a:latin typeface="Arial Unicode MS"/>
+              </a:defRPr>
+            </a:pPr>
+            <a:r>
+              <a:t>执行？</a:t>
+            </a:r>
+          </a:p>
+        </p:txBody>
+      </p:sp>
+      <p:sp>
+        <p:nvSpPr>
+          <p:cNvPr id="25" name="Rounded Rectangle 24"/>
           <p:cNvSpPr/>
           <p:nvPr/>
         </p:nvSpPr>
         <p:spPr>
           <a:xfrm>
-            <a:off x="6172200" y="4553712"/>
-            <a:ext cx="5440680" cy="1143000"/>
+            <a:off x="4297679" y="3246120"/>
+            <a:ext cx="3566160" cy="2194560"/>
           </a:xfrm>
           <a:prstGeom prst="roundRect">
             <a:avLst>
@@ -24118,14 +25626,463 @@
       </p:sp>
       <p:sp>
         <p:nvSpPr>
+          <p:cNvPr id="26" name="TextBox 25"/>
+          <p:cNvSpPr txBox="1"/>
+          <p:nvPr/>
+        </p:nvSpPr>
+        <p:spPr>
+          <a:xfrm>
+            <a:off x="4480559" y="3383279"/>
+            <a:ext cx="3200400" cy="283464"/>
+          </a:xfrm>
+          <a:prstGeom prst="rect">
+            <a:avLst/>
+          </a:prstGeom>
+          <a:noFill/>
+        </p:spPr>
+        <p:txBody>
+          <a:bodyPr wrap="none" lIns="0" rIns="0" tIns="0" bIns="0">
+            <a:spAutoFit/>
+          </a:bodyPr>
+          <a:lstStyle/>
+          <a:p>
+            <a:pPr>
+              <a:lnSpc>
+                <a:spcPts val="2196"/>
+              </a:lnSpc>
+              <a:spcBef>
+                <a:spcPts val="0"/>
+              </a:spcBef>
+              <a:spcAft>
+                <a:spcPts val="0"/>
+              </a:spcAft>
+              <a:defRPr sz="1800" b="1">
+                <a:solidFill>
+                  <a:srgbClr val="2458C6"/>
+                </a:solidFill>
+                <a:latin typeface="Arial Unicode MS"/>
+              </a:defRPr>
+            </a:pPr>
+            <a:r>
+              <a:t>02  Embedding</a:t>
+            </a:r>
+          </a:p>
+        </p:txBody>
+      </p:sp>
+      <p:sp>
+        <p:nvSpPr>
+          <p:cNvPr id="27" name="TextBox 26"/>
+          <p:cNvSpPr txBox="1"/>
+          <p:nvPr/>
+        </p:nvSpPr>
+        <p:spPr>
+          <a:xfrm>
+            <a:off x="4489703" y="3749039"/>
+            <a:ext cx="3182112" cy="603504"/>
+          </a:xfrm>
+          <a:prstGeom prst="rect">
+            <a:avLst/>
+          </a:prstGeom>
+          <a:noFill/>
+        </p:spPr>
+        <p:txBody>
+          <a:bodyPr wrap="none" lIns="0" rIns="0" tIns="0" bIns="0">
+            <a:spAutoFit/>
+          </a:bodyPr>
+          <a:lstStyle/>
+          <a:p>
+            <a:pPr>
+              <a:lnSpc>
+                <a:spcPts val="2440"/>
+              </a:lnSpc>
+              <a:spcBef>
+                <a:spcPts val="0"/>
+              </a:spcBef>
+              <a:spcAft>
+                <a:spcPts val="0"/>
+              </a:spcAft>
+              <a:defRPr sz="2000" b="1">
+                <a:solidFill>
+                  <a:srgbClr val="2458C6"/>
+                </a:solidFill>
+                <a:latin typeface="Arial Unicode MS"/>
+              </a:defRPr>
+            </a:pPr>
+            <a:r>
+              <a:t>ID → 向量 [B,T,D]</a:t>
+            </a:r>
+          </a:p>
+        </p:txBody>
+      </p:sp>
+      <p:sp>
+        <p:nvSpPr>
+          <p:cNvPr id="28" name="TextBox 27"/>
+          <p:cNvSpPr txBox="1"/>
+          <p:nvPr/>
+        </p:nvSpPr>
+        <p:spPr>
+          <a:xfrm>
+            <a:off x="4489703" y="4416552"/>
+            <a:ext cx="3182112" cy="292608"/>
+          </a:xfrm>
+          <a:prstGeom prst="rect">
+            <a:avLst/>
+          </a:prstGeom>
+          <a:noFill/>
+        </p:spPr>
+        <p:txBody>
+          <a:bodyPr wrap="none" lIns="0" rIns="0" tIns="0" bIns="0">
+            <a:spAutoFit/>
+          </a:bodyPr>
+          <a:lstStyle/>
+          <a:p>
+            <a:pPr>
+              <a:lnSpc>
+                <a:spcPts val="2196"/>
+              </a:lnSpc>
+              <a:spcBef>
+                <a:spcPts val="0"/>
+              </a:spcBef>
+              <a:spcAft>
+                <a:spcPts val="0"/>
+              </a:spcAft>
+              <a:defRPr sz="1800" b="0">
+                <a:solidFill>
+                  <a:srgbClr val="14263D"/>
+                </a:solidFill>
+                <a:latin typeface="Arial Unicode MS"/>
+              </a:defRPr>
+            </a:pPr>
+            <a:r>
+              <a:t>上节课：人工二维向量。</a:t>
+            </a:r>
+          </a:p>
+        </p:txBody>
+      </p:sp>
+      <p:sp>
+        <p:nvSpPr>
+          <p:cNvPr id="29" name="TextBox 28"/>
+          <p:cNvSpPr txBox="1"/>
+          <p:nvPr/>
+        </p:nvSpPr>
+        <p:spPr>
+          <a:xfrm>
+            <a:off x="4489703" y="4750308"/>
+            <a:ext cx="3182112" cy="571500"/>
+          </a:xfrm>
+          <a:prstGeom prst="rect">
+            <a:avLst/>
+          </a:prstGeom>
+          <a:noFill/>
+        </p:spPr>
+        <p:txBody>
+          <a:bodyPr wrap="none" lIns="0" rIns="0" tIns="0" bIns="0">
+            <a:spAutoFit/>
+          </a:bodyPr>
+          <a:lstStyle/>
+          <a:p>
+            <a:pPr>
+              <a:lnSpc>
+                <a:spcPts val="2196"/>
+              </a:lnSpc>
+              <a:spcBef>
+                <a:spcPts val="0"/>
+              </a:spcBef>
+              <a:spcAft>
+                <a:spcPts val="0"/>
+              </a:spcAft>
+              <a:defRPr sz="1800" b="0">
+                <a:solidFill>
+                  <a:srgbClr val="14263D"/>
+                </a:solidFill>
+                <a:latin typeface="Arial Unicode MS"/>
+              </a:defRPr>
+            </a:pPr>
+            <a:r>
+              <a:t>今天：怎样查表、怎样通过训</a:t>
+            </a:r>
+          </a:p>
+          <a:p>
+            <a:pPr>
+              <a:lnSpc>
+                <a:spcPts val="2196"/>
+              </a:lnSpc>
+              <a:spcBef>
+                <a:spcPts val="0"/>
+              </a:spcBef>
+              <a:spcAft>
+                <a:spcPts val="0"/>
+              </a:spcAft>
+              <a:defRPr sz="1800" b="0">
+                <a:solidFill>
+                  <a:srgbClr val="14263D"/>
+                </a:solidFill>
+                <a:latin typeface="Arial Unicode MS"/>
+              </a:defRPr>
+            </a:pPr>
+            <a:r>
+              <a:t>练更新？</a:t>
+            </a:r>
+          </a:p>
+        </p:txBody>
+      </p:sp>
+      <p:sp>
+        <p:nvSpPr>
+          <p:cNvPr id="30" name="Rounded Rectangle 29"/>
+          <p:cNvSpPr/>
+          <p:nvPr/>
+        </p:nvSpPr>
+        <p:spPr>
+          <a:xfrm>
+            <a:off x="8046719" y="3246120"/>
+            <a:ext cx="3566160" cy="2194560"/>
+          </a:xfrm>
+          <a:prstGeom prst="roundRect">
+            <a:avLst>
+              <a:gd name="adj" fmla="val 6000"/>
+            </a:avLst>
+          </a:prstGeom>
+          <a:solidFill>
+            <a:srgbClr val="FFFFFF"/>
+          </a:solidFill>
+          <a:ln>
+            <a:noFill/>
+          </a:ln>
+        </p:spPr>
+        <p:style>
+          <a:lnRef idx="1">
+            <a:schemeClr val="accent1"/>
+          </a:lnRef>
+          <a:fillRef idx="3">
+            <a:schemeClr val="accent1"/>
+          </a:fillRef>
+          <a:effectRef idx="2">
+            <a:schemeClr val="accent1"/>
+          </a:effectRef>
+          <a:fontRef idx="minor">
+            <a:schemeClr val="lt1"/>
+          </a:fontRef>
+        </p:style>
+        <p:txBody>
+          <a:bodyPr rtlCol="0" anchor="ctr"/>
+          <a:lstStyle/>
+          <a:p>
+            <a:pPr algn="ctr"/>
+          </a:p>
+        </p:txBody>
+      </p:sp>
+      <p:sp>
+        <p:nvSpPr>
+          <p:cNvPr id="31" name="TextBox 30"/>
+          <p:cNvSpPr txBox="1"/>
+          <p:nvPr/>
+        </p:nvSpPr>
+        <p:spPr>
+          <a:xfrm>
+            <a:off x="8229599" y="3383279"/>
+            <a:ext cx="3200400" cy="283464"/>
+          </a:xfrm>
+          <a:prstGeom prst="rect">
+            <a:avLst/>
+          </a:prstGeom>
+          <a:noFill/>
+        </p:spPr>
+        <p:txBody>
+          <a:bodyPr wrap="none" lIns="0" rIns="0" tIns="0" bIns="0">
+            <a:spAutoFit/>
+          </a:bodyPr>
+          <a:lstStyle/>
+          <a:p>
+            <a:pPr>
+              <a:lnSpc>
+                <a:spcPts val="2196"/>
+              </a:lnSpc>
+              <a:spcBef>
+                <a:spcPts val="0"/>
+              </a:spcBef>
+              <a:spcAft>
+                <a:spcPts val="0"/>
+              </a:spcAft>
+              <a:defRPr sz="1800" b="1">
+                <a:solidFill>
+                  <a:srgbClr val="2458C6"/>
+                </a:solidFill>
+                <a:latin typeface="Arial Unicode MS"/>
+              </a:defRPr>
+            </a:pPr>
+            <a:r>
+              <a:t>03  位置编码</a:t>
+            </a:r>
+          </a:p>
+        </p:txBody>
+      </p:sp>
+      <p:sp>
+        <p:nvSpPr>
+          <p:cNvPr id="32" name="TextBox 31"/>
+          <p:cNvSpPr txBox="1"/>
+          <p:nvPr/>
+        </p:nvSpPr>
+        <p:spPr>
+          <a:xfrm>
+            <a:off x="8238744" y="3749039"/>
+            <a:ext cx="3182112" cy="603504"/>
+          </a:xfrm>
+          <a:prstGeom prst="rect">
+            <a:avLst/>
+          </a:prstGeom>
+          <a:noFill/>
+        </p:spPr>
+        <p:txBody>
+          <a:bodyPr wrap="none" lIns="0" rIns="0" tIns="0" bIns="0">
+            <a:spAutoFit/>
+          </a:bodyPr>
+          <a:lstStyle/>
+          <a:p>
+            <a:pPr>
+              <a:lnSpc>
+                <a:spcPts val="2440"/>
+              </a:lnSpc>
+              <a:spcBef>
+                <a:spcPts val="0"/>
+              </a:spcBef>
+              <a:spcAft>
+                <a:spcPts val="0"/>
+              </a:spcAft>
+              <a:defRPr sz="2000" b="1">
+                <a:solidFill>
+                  <a:srgbClr val="2458C6"/>
+                </a:solidFill>
+                <a:latin typeface="Arial Unicode MS"/>
+              </a:defRPr>
+            </a:pPr>
+            <a:r>
+              <a:t>位置 t → 注意力的位置关系</a:t>
+            </a:r>
+          </a:p>
+        </p:txBody>
+      </p:sp>
+      <p:sp>
+        <p:nvSpPr>
+          <p:cNvPr id="33" name="TextBox 32"/>
+          <p:cNvSpPr txBox="1"/>
+          <p:nvPr/>
+        </p:nvSpPr>
+        <p:spPr>
+          <a:xfrm>
+            <a:off x="8238744" y="4416552"/>
+            <a:ext cx="3182112" cy="292608"/>
+          </a:xfrm>
+          <a:prstGeom prst="rect">
+            <a:avLst/>
+          </a:prstGeom>
+          <a:noFill/>
+        </p:spPr>
+        <p:txBody>
+          <a:bodyPr wrap="none" lIns="0" rIns="0" tIns="0" bIns="0">
+            <a:spAutoFit/>
+          </a:bodyPr>
+          <a:lstStyle/>
+          <a:p>
+            <a:pPr>
+              <a:lnSpc>
+                <a:spcPts val="2196"/>
+              </a:lnSpc>
+              <a:spcBef>
+                <a:spcPts val="0"/>
+              </a:spcBef>
+              <a:spcAft>
+                <a:spcPts val="0"/>
+              </a:spcAft>
+              <a:defRPr sz="1800" b="0">
+                <a:solidFill>
+                  <a:srgbClr val="14263D"/>
+                </a:solidFill>
+                <a:latin typeface="Arial Unicode MS"/>
+              </a:defRPr>
+            </a:pPr>
+            <a:r>
+              <a:t>上节课：认识顺序的作用。</a:t>
+            </a:r>
+          </a:p>
+        </p:txBody>
+      </p:sp>
+      <p:sp>
+        <p:nvSpPr>
+          <p:cNvPr id="34" name="TextBox 33"/>
+          <p:cNvSpPr txBox="1"/>
+          <p:nvPr/>
+        </p:nvSpPr>
+        <p:spPr>
+          <a:xfrm>
+            <a:off x="8238744" y="4750308"/>
+            <a:ext cx="3182112" cy="571500"/>
+          </a:xfrm>
+          <a:prstGeom prst="rect">
+            <a:avLst/>
+          </a:prstGeom>
+          <a:noFill/>
+        </p:spPr>
+        <p:txBody>
+          <a:bodyPr wrap="none" lIns="0" rIns="0" tIns="0" bIns="0">
+            <a:spAutoFit/>
+          </a:bodyPr>
+          <a:lstStyle/>
+          <a:p>
+            <a:pPr>
+              <a:lnSpc>
+                <a:spcPts val="2196"/>
+              </a:lnSpc>
+              <a:spcBef>
+                <a:spcPts val="0"/>
+              </a:spcBef>
+              <a:spcAft>
+                <a:spcPts val="0"/>
+              </a:spcAft>
+              <a:defRPr sz="1800" b="0">
+                <a:solidFill>
+                  <a:srgbClr val="14263D"/>
+                </a:solidFill>
+                <a:latin typeface="Arial Unicode MS"/>
+              </a:defRPr>
+            </a:pPr>
+            <a:r>
+              <a:t>今天：输入加 PE，或在 Q/K </a:t>
+            </a:r>
+          </a:p>
+          <a:p>
+            <a:pPr>
+              <a:lnSpc>
+                <a:spcPts val="2196"/>
+              </a:lnSpc>
+              <a:spcBef>
+                <a:spcPts val="0"/>
+              </a:spcBef>
+              <a:spcAft>
+                <a:spcPts val="0"/>
+              </a:spcAft>
+              <a:defRPr sz="1800" b="0">
+                <a:solidFill>
+                  <a:srgbClr val="14263D"/>
+                </a:solidFill>
+                <a:latin typeface="Arial Unicode MS"/>
+              </a:defRPr>
+            </a:pPr>
+            <a:r>
+              <a:t>上用 RoPE。</a:t>
+            </a:r>
+          </a:p>
+        </p:txBody>
+      </p:sp>
+      <p:sp>
+        <p:nvSpPr>
           <p:cNvPr id="35" name="TextBox 34"/>
           <p:cNvSpPr txBox="1"/>
           <p:nvPr/>
         </p:nvSpPr>
         <p:spPr>
           <a:xfrm>
-            <a:off x="6355080" y="4690872"/>
-            <a:ext cx="5074920" cy="283464"/>
+            <a:off x="777240" y="5559552"/>
+            <a:ext cx="10561320" cy="283464"/>
           </a:xfrm>
           <a:prstGeom prst="rect">
             <a:avLst/>
@@ -24148,96 +26105,6 @@
               <a:spcAft>
                 <a:spcPts val="0"/>
               </a:spcAft>
-              <a:defRPr sz="1800" b="1">
-                <a:solidFill>
-                  <a:srgbClr val="2458C6"/>
-                </a:solidFill>
-                <a:latin typeface="Arial Unicode MS"/>
-              </a:defRPr>
-            </a:pPr>
-            <a:r>
-              <a:t>序列相关开销：稠密 scores 的格数</a:t>
-            </a:r>
-          </a:p>
-        </p:txBody>
-      </p:sp>
-      <p:sp>
-        <p:nvSpPr>
-          <p:cNvPr id="36" name="TextBox 35"/>
-          <p:cNvSpPr txBox="1"/>
-          <p:nvPr/>
-        </p:nvSpPr>
-        <p:spPr>
-          <a:xfrm>
-            <a:off x="6391656" y="5020056"/>
-            <a:ext cx="5001768" cy="475488"/>
-          </a:xfrm>
-          <a:prstGeom prst="rect">
-            <a:avLst/>
-          </a:prstGeom>
-          <a:noFill/>
-        </p:spPr>
-        <p:txBody>
-          <a:bodyPr wrap="none" lIns="0" rIns="0" tIns="0" bIns="0">
-            <a:spAutoFit/>
-          </a:bodyPr>
-          <a:lstStyle/>
-          <a:p>
-            <a:pPr>
-              <a:lnSpc>
-                <a:spcPts val="2684"/>
-              </a:lnSpc>
-              <a:spcBef>
-                <a:spcPts val="0"/>
-              </a:spcBef>
-              <a:spcAft>
-                <a:spcPts val="0"/>
-              </a:spcAft>
-              <a:defRPr sz="2200" b="0">
-                <a:solidFill>
-                  <a:srgbClr val="087F8C"/>
-                </a:solidFill>
-                <a:latin typeface="Arial Unicode MS"/>
-              </a:defRPr>
-            </a:pPr>
-            <a:r>
-              <a:t>T=6 → 36格；T=2 → 4格</a:t>
-            </a:r>
-          </a:p>
-        </p:txBody>
-      </p:sp>
-      <p:sp>
-        <p:nvSpPr>
-          <p:cNvPr id="37" name="TextBox 36"/>
-          <p:cNvSpPr txBox="1"/>
-          <p:nvPr/>
-        </p:nvSpPr>
-        <p:spPr>
-          <a:xfrm>
-            <a:off x="768096" y="5815584"/>
-            <a:ext cx="10561320" cy="278892"/>
-          </a:xfrm>
-          <a:prstGeom prst="rect">
-            <a:avLst/>
-          </a:prstGeom>
-          <a:noFill/>
-        </p:spPr>
-        <p:txBody>
-          <a:bodyPr wrap="none" lIns="0" rIns="0" tIns="0" bIns="0">
-            <a:spAutoFit/>
-          </a:bodyPr>
-          <a:lstStyle/>
-          <a:p>
-            <a:pPr>
-              <a:lnSpc>
-                <a:spcPts val="2196"/>
-              </a:lnSpc>
-              <a:spcBef>
-                <a:spcPts val="0"/>
-              </a:spcBef>
-              <a:spcAft>
-                <a:spcPts val="0"/>
-              </a:spcAft>
               <a:defRPr sz="1800" b="0">
                 <a:solidFill>
                   <a:srgbClr val="475569"/>
@@ -24246,7 +26113,7 @@
               </a:defRPr>
             </a:pPr>
             <a:r>
-              <a:t>输出投影还涉及 T×D×V；上面只比较单份E与稠密scores，不代表全部模型成本。</a:t>
+              <a:t>位置的两条路径是不同方案；上节课的数值来自人工参数，今天逐步补全真实机制。</a:t>
             </a:r>
           </a:p>
         </p:txBody>

</xml_diff>